<commit_message>
fix: align Unstop artifacts — sub-4min video and 11-slide deck
Trim demo to ~3:59 and expand pitch deck/PDF with team, tech, scalability,
and roadmap so the form checklist is covered.

Co-authored-by: Cursor <cursoragent@cursor.com>
</commit_message>
<xml_diff>
--- a/aegis/submission/Aegis_Guard_ET_AI_Hackathon_Problem2.pptx
+++ b/aegis/submission/Aegis_Guard_ET_AI_Hackathon_Problem2.pptx
@@ -13,6 +13,9 @@
     <p:sldId id="261" r:id="rId12"/>
     <p:sldId id="262" r:id="rId13"/>
     <p:sldId id="263" r:id="rId14"/>
+    <p:sldId id="264" r:id="rId15"/>
+    <p:sldId id="265" r:id="rId16"/>
+    <p:sldId id="266" r:id="rId17"/>
   </p:sldIdLst>
   <p:sldSz cx="12191695" cy="6858000" type="screen4x3"/>
   <p:notesSz cx="6858000" cy="9144000"/>
@@ -3189,7 +3192,7 @@
         </p:nvSpPr>
         <p:spPr>
           <a:xfrm>
-            <a:off x="731520" y="1463040"/>
+            <a:off x="731520" y="1280160"/>
             <a:ext cx="10515600" cy="914400"/>
           </a:xfrm>
           <a:prstGeom prst="rect">
@@ -3223,8 +3226,8 @@
         </p:nvSpPr>
         <p:spPr>
           <a:xfrm>
-            <a:off x="731520" y="2286000"/>
-            <a:ext cx="10515600" cy="1097280"/>
+            <a:off x="731520" y="2103120"/>
+            <a:ext cx="10515600" cy="1280160"/>
           </a:xfrm>
           <a:prstGeom prst="rect">
             <a:avLst/>
@@ -3255,7 +3258,18 @@
                 </a:solidFill>
                 <a:latin typeface="Arial"/>
               </a:rPr>
-              <a:t>ET AI Hackathon: Agentic Edition  ·  Problem 2  ·  Solo</a:t>
+              <a:t>Agentic Cybersecurity  ·  Solo build  ·  Python</a:t>
+            </a:r>
+          </a:p>
+          <a:p>
+            <a:r>
+              <a:rPr sz="1500" b="0">
+                <a:solidFill>
+                  <a:srgbClr val="E6F5F2"/>
+                </a:solidFill>
+                <a:latin typeface="Arial"/>
+              </a:rPr>
+              <a:t>Team: Abhishek — Product · Architecture · Full-stack implementation</a:t>
             </a:r>
           </a:p>
         </p:txBody>
@@ -3268,7 +3282,7 @@
         </p:nvSpPr>
         <p:spPr>
           <a:xfrm>
-            <a:off x="731520" y="5669280"/>
+            <a:off x="731520" y="5623560"/>
             <a:ext cx="10515600" cy="822960"/>
           </a:xfrm>
           <a:prstGeom prst="rect">
@@ -3283,13 +3297,13 @@
           <a:lstStyle/>
           <a:p>
             <a:r>
-              <a:rPr sz="2000" b="1">
+              <a:rPr sz="1600" b="1">
                 <a:solidFill>
                   <a:srgbClr val="FFFFFF"/>
                 </a:solidFill>
                 <a:latin typeface="Arial"/>
               </a:rPr>
-              <a:t>Self-estimated 9-blocker:  F3  /  D2</a:t>
+              <a:t>Live demo  ·  aegis-prompt-injection-firewall.vercel.app</a:t>
             </a:r>
           </a:p>
           <a:p>
@@ -3300,7 +3314,898 @@
                 </a:solidFill>
                 <a:latin typeface="Arial"/>
               </a:rPr>
-              <a:t>Live demo  ·  aegis-prompt-injection-firewall.vercel.app</a:t>
+              <a:t>GitHub  ·  github.com/krabhi75/aegis-prompt-injection-firewall</a:t>
+            </a:r>
+          </a:p>
+        </p:txBody>
+      </p:sp>
+    </p:spTree>
+  </p:cSld>
+  <p:clrMapOvr>
+    <a:masterClrMapping/>
+  </p:clrMapOvr>
+</p:sld>
+</file>
+
+<file path=ppt/slides/slide10.xml><?xml version="1.0" encoding="utf-8"?>
+<p:sld xmlns:a="http://schemas.openxmlformats.org/drawingml/2006/main" xmlns:p="http://schemas.openxmlformats.org/presentationml/2006/main" xmlns:r="http://schemas.openxmlformats.org/officeDocument/2006/relationships">
+  <p:cSld>
+    <p:spTree>
+      <p:nvGrpSpPr>
+        <p:cNvPr id="1" name=""/>
+        <p:cNvGrpSpPr/>
+        <p:nvPr/>
+      </p:nvGrpSpPr>
+      <p:grpSpPr/>
+      <p:sp>
+        <p:nvSpPr>
+          <p:cNvPr id="2" name="Rectangle 1"/>
+          <p:cNvSpPr/>
+          <p:nvPr/>
+        </p:nvSpPr>
+        <p:spPr>
+          <a:xfrm>
+            <a:off x="0" y="0"/>
+            <a:ext cx="12191695" cy="6858000"/>
+          </a:xfrm>
+          <a:prstGeom prst="rect">
+            <a:avLst/>
+          </a:prstGeom>
+          <a:solidFill>
+            <a:srgbClr val="F4F7F6"/>
+          </a:solidFill>
+          <a:ln>
+            <a:noFill/>
+          </a:ln>
+        </p:spPr>
+        <p:style>
+          <a:lnRef idx="1">
+            <a:schemeClr val="accent1"/>
+          </a:lnRef>
+          <a:fillRef idx="3">
+            <a:schemeClr val="accent1"/>
+          </a:fillRef>
+          <a:effectRef idx="2">
+            <a:schemeClr val="accent1"/>
+          </a:effectRef>
+          <a:fontRef idx="minor">
+            <a:schemeClr val="lt1"/>
+          </a:fontRef>
+        </p:style>
+        <p:txBody>
+          <a:bodyPr rtlCol="0" anchor="ctr"/>
+          <a:lstStyle/>
+          <a:p>
+            <a:pPr algn="ctr"/>
+          </a:p>
+        </p:txBody>
+      </p:sp>
+      <p:sp>
+        <p:nvSpPr>
+          <p:cNvPr id="3" name="Rectangle 2"/>
+          <p:cNvSpPr/>
+          <p:nvPr/>
+        </p:nvSpPr>
+        <p:spPr>
+          <a:xfrm>
+            <a:off x="0" y="0"/>
+            <a:ext cx="12191695" cy="73152"/>
+          </a:xfrm>
+          <a:prstGeom prst="rect">
+            <a:avLst/>
+          </a:prstGeom>
+          <a:solidFill>
+            <a:srgbClr val="0F766E"/>
+          </a:solidFill>
+          <a:ln>
+            <a:noFill/>
+          </a:ln>
+        </p:spPr>
+        <p:style>
+          <a:lnRef idx="1">
+            <a:schemeClr val="accent1"/>
+          </a:lnRef>
+          <a:fillRef idx="3">
+            <a:schemeClr val="accent1"/>
+          </a:fillRef>
+          <a:effectRef idx="2">
+            <a:schemeClr val="accent1"/>
+          </a:effectRef>
+          <a:fontRef idx="minor">
+            <a:schemeClr val="lt1"/>
+          </a:fontRef>
+        </p:style>
+        <p:txBody>
+          <a:bodyPr rtlCol="0" anchor="ctr"/>
+          <a:lstStyle/>
+          <a:p>
+            <a:pPr algn="ctr"/>
+          </a:p>
+        </p:txBody>
+      </p:sp>
+      <p:sp>
+        <p:nvSpPr>
+          <p:cNvPr id="4" name="TextBox 3"/>
+          <p:cNvSpPr txBox="1"/>
+          <p:nvPr/>
+        </p:nvSpPr>
+        <p:spPr>
+          <a:xfrm>
+            <a:off x="640080" y="411480"/>
+            <a:ext cx="10972800" cy="640080"/>
+          </a:xfrm>
+          <a:prstGeom prst="rect">
+            <a:avLst/>
+          </a:prstGeom>
+          <a:noFill/>
+        </p:spPr>
+        <p:txBody>
+          <a:bodyPr wrap="none">
+            <a:spAutoFit/>
+          </a:bodyPr>
+          <a:lstStyle/>
+          <a:p>
+            <a:r>
+              <a:rPr sz="3200" b="1">
+                <a:solidFill>
+                  <a:srgbClr val="0B1F1A"/>
+                </a:solidFill>
+                <a:latin typeface="Arial"/>
+              </a:rPr>
+              <a:t>Future roadmap</a:t>
+            </a:r>
+          </a:p>
+        </p:txBody>
+      </p:sp>
+      <p:sp>
+        <p:nvSpPr>
+          <p:cNvPr id="5" name="Rounded Rectangle 4"/>
+          <p:cNvSpPr/>
+          <p:nvPr/>
+        </p:nvSpPr>
+        <p:spPr>
+          <a:xfrm>
+            <a:off x="640080" y="1234440"/>
+            <a:ext cx="3566160" cy="4206240"/>
+          </a:xfrm>
+          <a:prstGeom prst="roundRect">
+            <a:avLst/>
+          </a:prstGeom>
+          <a:solidFill>
+            <a:srgbClr val="FFFFFF"/>
+          </a:solidFill>
+          <a:ln>
+            <a:solidFill>
+              <a:srgbClr val="D9E2DE"/>
+            </a:solidFill>
+          </a:ln>
+        </p:spPr>
+        <p:style>
+          <a:lnRef idx="1">
+            <a:schemeClr val="accent1"/>
+          </a:lnRef>
+          <a:fillRef idx="3">
+            <a:schemeClr val="accent1"/>
+          </a:fillRef>
+          <a:effectRef idx="2">
+            <a:schemeClr val="accent1"/>
+          </a:effectRef>
+          <a:fontRef idx="minor">
+            <a:schemeClr val="lt1"/>
+          </a:fontRef>
+        </p:style>
+        <p:txBody>
+          <a:bodyPr rtlCol="0" anchor="ctr"/>
+          <a:lstStyle/>
+          <a:p>
+            <a:pPr algn="ctr"/>
+          </a:p>
+        </p:txBody>
+      </p:sp>
+      <p:sp>
+        <p:nvSpPr>
+          <p:cNvPr id="6" name="Rectangle 5"/>
+          <p:cNvSpPr/>
+          <p:nvPr/>
+        </p:nvSpPr>
+        <p:spPr>
+          <a:xfrm>
+            <a:off x="640080" y="1234440"/>
+            <a:ext cx="73152" cy="4206240"/>
+          </a:xfrm>
+          <a:prstGeom prst="rect">
+            <a:avLst/>
+          </a:prstGeom>
+          <a:solidFill>
+            <a:srgbClr val="0F766E"/>
+          </a:solidFill>
+          <a:ln>
+            <a:noFill/>
+          </a:ln>
+        </p:spPr>
+        <p:style>
+          <a:lnRef idx="1">
+            <a:schemeClr val="accent1"/>
+          </a:lnRef>
+          <a:fillRef idx="3">
+            <a:schemeClr val="accent1"/>
+          </a:fillRef>
+          <a:effectRef idx="2">
+            <a:schemeClr val="accent1"/>
+          </a:effectRef>
+          <a:fontRef idx="minor">
+            <a:schemeClr val="lt1"/>
+          </a:fontRef>
+        </p:style>
+        <p:txBody>
+          <a:bodyPr rtlCol="0" anchor="ctr"/>
+          <a:lstStyle/>
+          <a:p>
+            <a:pPr algn="ctr"/>
+          </a:p>
+        </p:txBody>
+      </p:sp>
+      <p:sp>
+        <p:nvSpPr>
+          <p:cNvPr id="7" name="TextBox 6"/>
+          <p:cNvSpPr txBox="1"/>
+          <p:nvPr/>
+        </p:nvSpPr>
+        <p:spPr>
+          <a:xfrm>
+            <a:off x="868680" y="1417320"/>
+            <a:ext cx="3200400" cy="365760"/>
+          </a:xfrm>
+          <a:prstGeom prst="rect">
+            <a:avLst/>
+          </a:prstGeom>
+          <a:noFill/>
+        </p:spPr>
+        <p:txBody>
+          <a:bodyPr wrap="none">
+            <a:spAutoFit/>
+          </a:bodyPr>
+          <a:lstStyle/>
+          <a:p>
+            <a:r>
+              <a:rPr sz="1400" b="1">
+                <a:solidFill>
+                  <a:srgbClr val="115E59"/>
+                </a:solidFill>
+                <a:latin typeface="Arial"/>
+              </a:rPr>
+              <a:t>Near term</a:t>
+            </a:r>
+          </a:p>
+        </p:txBody>
+      </p:sp>
+      <p:sp>
+        <p:nvSpPr>
+          <p:cNvPr id="8" name="TextBox 7"/>
+          <p:cNvSpPr txBox="1"/>
+          <p:nvPr/>
+        </p:nvSpPr>
+        <p:spPr>
+          <a:xfrm>
+            <a:off x="868680" y="1828800"/>
+            <a:ext cx="3200400" cy="3428999"/>
+          </a:xfrm>
+          <a:prstGeom prst="rect">
+            <a:avLst/>
+          </a:prstGeom>
+          <a:noFill/>
+        </p:spPr>
+        <p:txBody>
+          <a:bodyPr wrap="square">
+            <a:spAutoFit/>
+          </a:bodyPr>
+          <a:lstStyle/>
+          <a:p>
+            <a:r>
+              <a:rPr sz="1200" b="0">
+                <a:solidFill>
+                  <a:srgbClr val="5B6F68"/>
+                </a:solidFill>
+                <a:latin typeface="Arial"/>
+              </a:rPr>
+              <a:t>Deeper OCR / Word paths · richer policy packs · SIEM / webhook exporters · stronger multi-tenant audit.</a:t>
+            </a:r>
+          </a:p>
+        </p:txBody>
+      </p:sp>
+      <p:sp>
+        <p:nvSpPr>
+          <p:cNvPr id="9" name="Rounded Rectangle 8"/>
+          <p:cNvSpPr/>
+          <p:nvPr/>
+        </p:nvSpPr>
+        <p:spPr>
+          <a:xfrm>
+            <a:off x="4389120" y="1234440"/>
+            <a:ext cx="3566160" cy="4206240"/>
+          </a:xfrm>
+          <a:prstGeom prst="roundRect">
+            <a:avLst/>
+          </a:prstGeom>
+          <a:solidFill>
+            <a:srgbClr val="FFFFFF"/>
+          </a:solidFill>
+          <a:ln>
+            <a:solidFill>
+              <a:srgbClr val="D9E2DE"/>
+            </a:solidFill>
+          </a:ln>
+        </p:spPr>
+        <p:style>
+          <a:lnRef idx="1">
+            <a:schemeClr val="accent1"/>
+          </a:lnRef>
+          <a:fillRef idx="3">
+            <a:schemeClr val="accent1"/>
+          </a:fillRef>
+          <a:effectRef idx="2">
+            <a:schemeClr val="accent1"/>
+          </a:effectRef>
+          <a:fontRef idx="minor">
+            <a:schemeClr val="lt1"/>
+          </a:fontRef>
+        </p:style>
+        <p:txBody>
+          <a:bodyPr rtlCol="0" anchor="ctr"/>
+          <a:lstStyle/>
+          <a:p>
+            <a:pPr algn="ctr"/>
+          </a:p>
+        </p:txBody>
+      </p:sp>
+      <p:sp>
+        <p:nvSpPr>
+          <p:cNvPr id="10" name="Rectangle 9"/>
+          <p:cNvSpPr/>
+          <p:nvPr/>
+        </p:nvSpPr>
+        <p:spPr>
+          <a:xfrm>
+            <a:off x="4389120" y="1234440"/>
+            <a:ext cx="73152" cy="4206240"/>
+          </a:xfrm>
+          <a:prstGeom prst="rect">
+            <a:avLst/>
+          </a:prstGeom>
+          <a:solidFill>
+            <a:srgbClr val="0F766E"/>
+          </a:solidFill>
+          <a:ln>
+            <a:noFill/>
+          </a:ln>
+        </p:spPr>
+        <p:style>
+          <a:lnRef idx="1">
+            <a:schemeClr val="accent1"/>
+          </a:lnRef>
+          <a:fillRef idx="3">
+            <a:schemeClr val="accent1"/>
+          </a:fillRef>
+          <a:effectRef idx="2">
+            <a:schemeClr val="accent1"/>
+          </a:effectRef>
+          <a:fontRef idx="minor">
+            <a:schemeClr val="lt1"/>
+          </a:fontRef>
+        </p:style>
+        <p:txBody>
+          <a:bodyPr rtlCol="0" anchor="ctr"/>
+          <a:lstStyle/>
+          <a:p>
+            <a:pPr algn="ctr"/>
+          </a:p>
+        </p:txBody>
+      </p:sp>
+      <p:sp>
+        <p:nvSpPr>
+          <p:cNvPr id="11" name="TextBox 10"/>
+          <p:cNvSpPr txBox="1"/>
+          <p:nvPr/>
+        </p:nvSpPr>
+        <p:spPr>
+          <a:xfrm>
+            <a:off x="4617720" y="1417320"/>
+            <a:ext cx="3200400" cy="365760"/>
+          </a:xfrm>
+          <a:prstGeom prst="rect">
+            <a:avLst/>
+          </a:prstGeom>
+          <a:noFill/>
+        </p:spPr>
+        <p:txBody>
+          <a:bodyPr wrap="none">
+            <a:spAutoFit/>
+          </a:bodyPr>
+          <a:lstStyle/>
+          <a:p>
+            <a:r>
+              <a:rPr sz="1400" b="1">
+                <a:solidFill>
+                  <a:srgbClr val="115E59"/>
+                </a:solidFill>
+                <a:latin typeface="Arial"/>
+              </a:rPr>
+              <a:t>Mid term</a:t>
+            </a:r>
+          </a:p>
+        </p:txBody>
+      </p:sp>
+      <p:sp>
+        <p:nvSpPr>
+          <p:cNvPr id="12" name="TextBox 11"/>
+          <p:cNvSpPr txBox="1"/>
+          <p:nvPr/>
+        </p:nvSpPr>
+        <p:spPr>
+          <a:xfrm>
+            <a:off x="4617720" y="1828800"/>
+            <a:ext cx="3200400" cy="3428999"/>
+          </a:xfrm>
+          <a:prstGeom prst="rect">
+            <a:avLst/>
+          </a:prstGeom>
+          <a:noFill/>
+        </p:spPr>
+        <p:txBody>
+          <a:bodyPr wrap="square">
+            <a:spAutoFit/>
+          </a:bodyPr>
+          <a:lstStyle/>
+          <a:p>
+            <a:r>
+              <a:rPr sz="1200" b="0">
+                <a:solidFill>
+                  <a:srgbClr val="5B6F68"/>
+                </a:solidFill>
+                <a:latin typeface="Arial"/>
+              </a:rPr>
+              <a:t>Native SDK embeds · streaming scan for long docs · adaptive thresholds per agent role · red-team corpus growth.</a:t>
+            </a:r>
+          </a:p>
+        </p:txBody>
+      </p:sp>
+      <p:sp>
+        <p:nvSpPr>
+          <p:cNvPr id="13" name="Rounded Rectangle 12"/>
+          <p:cNvSpPr/>
+          <p:nvPr/>
+        </p:nvSpPr>
+        <p:spPr>
+          <a:xfrm>
+            <a:off x="8138160" y="1234440"/>
+            <a:ext cx="3383280" cy="4206240"/>
+          </a:xfrm>
+          <a:prstGeom prst="roundRect">
+            <a:avLst/>
+          </a:prstGeom>
+          <a:solidFill>
+            <a:srgbClr val="FFFFFF"/>
+          </a:solidFill>
+          <a:ln>
+            <a:solidFill>
+              <a:srgbClr val="D9E2DE"/>
+            </a:solidFill>
+          </a:ln>
+        </p:spPr>
+        <p:style>
+          <a:lnRef idx="1">
+            <a:schemeClr val="accent1"/>
+          </a:lnRef>
+          <a:fillRef idx="3">
+            <a:schemeClr val="accent1"/>
+          </a:fillRef>
+          <a:effectRef idx="2">
+            <a:schemeClr val="accent1"/>
+          </a:effectRef>
+          <a:fontRef idx="minor">
+            <a:schemeClr val="lt1"/>
+          </a:fontRef>
+        </p:style>
+        <p:txBody>
+          <a:bodyPr rtlCol="0" anchor="ctr"/>
+          <a:lstStyle/>
+          <a:p>
+            <a:pPr algn="ctr"/>
+          </a:p>
+        </p:txBody>
+      </p:sp>
+      <p:sp>
+        <p:nvSpPr>
+          <p:cNvPr id="14" name="Rectangle 13"/>
+          <p:cNvSpPr/>
+          <p:nvPr/>
+        </p:nvSpPr>
+        <p:spPr>
+          <a:xfrm>
+            <a:off x="8138160" y="1234440"/>
+            <a:ext cx="73152" cy="4206240"/>
+          </a:xfrm>
+          <a:prstGeom prst="rect">
+            <a:avLst/>
+          </a:prstGeom>
+          <a:solidFill>
+            <a:srgbClr val="0F766E"/>
+          </a:solidFill>
+          <a:ln>
+            <a:noFill/>
+          </a:ln>
+        </p:spPr>
+        <p:style>
+          <a:lnRef idx="1">
+            <a:schemeClr val="accent1"/>
+          </a:lnRef>
+          <a:fillRef idx="3">
+            <a:schemeClr val="accent1"/>
+          </a:fillRef>
+          <a:effectRef idx="2">
+            <a:schemeClr val="accent1"/>
+          </a:effectRef>
+          <a:fontRef idx="minor">
+            <a:schemeClr val="lt1"/>
+          </a:fontRef>
+        </p:style>
+        <p:txBody>
+          <a:bodyPr rtlCol="0" anchor="ctr"/>
+          <a:lstStyle/>
+          <a:p>
+            <a:pPr algn="ctr"/>
+          </a:p>
+        </p:txBody>
+      </p:sp>
+      <p:sp>
+        <p:nvSpPr>
+          <p:cNvPr id="15" name="TextBox 14"/>
+          <p:cNvSpPr txBox="1"/>
+          <p:nvPr/>
+        </p:nvSpPr>
+        <p:spPr>
+          <a:xfrm>
+            <a:off x="8366760" y="1417320"/>
+            <a:ext cx="3017520" cy="365760"/>
+          </a:xfrm>
+          <a:prstGeom prst="rect">
+            <a:avLst/>
+          </a:prstGeom>
+          <a:noFill/>
+        </p:spPr>
+        <p:txBody>
+          <a:bodyPr wrap="none">
+            <a:spAutoFit/>
+          </a:bodyPr>
+          <a:lstStyle/>
+          <a:p>
+            <a:r>
+              <a:rPr sz="1400" b="1">
+                <a:solidFill>
+                  <a:srgbClr val="115E59"/>
+                </a:solidFill>
+                <a:latin typeface="Arial"/>
+              </a:rPr>
+              <a:t>North star</a:t>
+            </a:r>
+          </a:p>
+        </p:txBody>
+      </p:sp>
+      <p:sp>
+        <p:nvSpPr>
+          <p:cNvPr id="16" name="TextBox 15"/>
+          <p:cNvSpPr txBox="1"/>
+          <p:nvPr/>
+        </p:nvSpPr>
+        <p:spPr>
+          <a:xfrm>
+            <a:off x="8366760" y="1828800"/>
+            <a:ext cx="3017520" cy="3428999"/>
+          </a:xfrm>
+          <a:prstGeom prst="rect">
+            <a:avLst/>
+          </a:prstGeom>
+          <a:noFill/>
+        </p:spPr>
+        <p:txBody>
+          <a:bodyPr wrap="square">
+            <a:spAutoFit/>
+          </a:bodyPr>
+          <a:lstStyle/>
+          <a:p>
+            <a:r>
+              <a:rPr sz="1200" b="0">
+                <a:solidFill>
+                  <a:srgbClr val="5B6F68"/>
+                </a:solidFill>
+                <a:latin typeface="Arial"/>
+              </a:rPr>
+              <a:t>Default runtime firewall for enterprise agents — twin + provenance + caps as industry pattern.</a:t>
+            </a:r>
+          </a:p>
+        </p:txBody>
+      </p:sp>
+      <p:sp>
+        <p:nvSpPr>
+          <p:cNvPr id="17" name="TextBox 16"/>
+          <p:cNvSpPr txBox="1"/>
+          <p:nvPr/>
+        </p:nvSpPr>
+        <p:spPr>
+          <a:xfrm>
+            <a:off x="548640" y="6446520"/>
+            <a:ext cx="9144000" cy="274320"/>
+          </a:xfrm>
+          <a:prstGeom prst="rect">
+            <a:avLst/>
+          </a:prstGeom>
+          <a:noFill/>
+        </p:spPr>
+        <p:txBody>
+          <a:bodyPr wrap="none">
+            <a:spAutoFit/>
+          </a:bodyPr>
+          <a:lstStyle/>
+          <a:p>
+            <a:r>
+              <a:rPr sz="1000" b="0">
+                <a:solidFill>
+                  <a:srgbClr val="5B6F68"/>
+                </a:solidFill>
+                <a:latin typeface="Arial"/>
+              </a:rPr>
+              <a:t>Aegis Guard  ·  ET AI Hackathon Problem 2  ·  Claim F3 / D2  ·  10</a:t>
+            </a:r>
+          </a:p>
+        </p:txBody>
+      </p:sp>
+      <p:sp>
+        <p:nvSpPr>
+          <p:cNvPr id="18" name="TextBox 17"/>
+          <p:cNvSpPr txBox="1"/>
+          <p:nvPr/>
+        </p:nvSpPr>
+        <p:spPr>
+          <a:xfrm>
+            <a:off x="10241280" y="6446520"/>
+            <a:ext cx="1371600" cy="274320"/>
+          </a:xfrm>
+          <a:prstGeom prst="rect">
+            <a:avLst/>
+          </a:prstGeom>
+          <a:noFill/>
+        </p:spPr>
+        <p:txBody>
+          <a:bodyPr wrap="none">
+            <a:spAutoFit/>
+          </a:bodyPr>
+          <a:lstStyle/>
+          <a:p>
+            <a:pPr algn="r"/>
+            <a:r>
+              <a:rPr sz="1000" b="0">
+                <a:solidFill>
+                  <a:srgbClr val="5B6F68"/>
+                </a:solidFill>
+                <a:latin typeface="Arial"/>
+              </a:rPr>
+              <a:t>10</a:t>
+            </a:r>
+          </a:p>
+        </p:txBody>
+      </p:sp>
+    </p:spTree>
+  </p:cSld>
+  <p:clrMapOvr>
+    <a:masterClrMapping/>
+  </p:clrMapOvr>
+</p:sld>
+</file>
+
+<file path=ppt/slides/slide11.xml><?xml version="1.0" encoding="utf-8"?>
+<p:sld xmlns:a="http://schemas.openxmlformats.org/drawingml/2006/main" xmlns:p="http://schemas.openxmlformats.org/presentationml/2006/main" xmlns:r="http://schemas.openxmlformats.org/officeDocument/2006/relationships">
+  <p:cSld>
+    <p:spTree>
+      <p:nvGrpSpPr>
+        <p:cNvPr id="1" name=""/>
+        <p:cNvGrpSpPr/>
+        <p:nvPr/>
+      </p:nvGrpSpPr>
+      <p:grpSpPr/>
+      <p:sp>
+        <p:nvSpPr>
+          <p:cNvPr id="2" name="Rectangle 1"/>
+          <p:cNvSpPr/>
+          <p:nvPr/>
+        </p:nvSpPr>
+        <p:spPr>
+          <a:xfrm>
+            <a:off x="0" y="0"/>
+            <a:ext cx="12191695" cy="6858000"/>
+          </a:xfrm>
+          <a:prstGeom prst="rect">
+            <a:avLst/>
+          </a:prstGeom>
+          <a:solidFill>
+            <a:srgbClr val="0B1F1A"/>
+          </a:solidFill>
+          <a:ln>
+            <a:noFill/>
+          </a:ln>
+        </p:spPr>
+        <p:style>
+          <a:lnRef idx="1">
+            <a:schemeClr val="accent1"/>
+          </a:lnRef>
+          <a:fillRef idx="3">
+            <a:schemeClr val="accent1"/>
+          </a:fillRef>
+          <a:effectRef idx="2">
+            <a:schemeClr val="accent1"/>
+          </a:effectRef>
+          <a:fontRef idx="minor">
+            <a:schemeClr val="lt1"/>
+          </a:fontRef>
+        </p:style>
+        <p:txBody>
+          <a:bodyPr rtlCol="0" anchor="ctr"/>
+          <a:lstStyle/>
+          <a:p>
+            <a:pPr algn="ctr"/>
+          </a:p>
+        </p:txBody>
+      </p:sp>
+      <p:sp>
+        <p:nvSpPr>
+          <p:cNvPr id="3" name="Rectangle 2"/>
+          <p:cNvSpPr/>
+          <p:nvPr/>
+        </p:nvSpPr>
+        <p:spPr>
+          <a:xfrm>
+            <a:off x="0" y="0"/>
+            <a:ext cx="109728" cy="6858000"/>
+          </a:xfrm>
+          <a:prstGeom prst="rect">
+            <a:avLst/>
+          </a:prstGeom>
+          <a:solidFill>
+            <a:srgbClr val="0F766E"/>
+          </a:solidFill>
+          <a:ln>
+            <a:noFill/>
+          </a:ln>
+        </p:spPr>
+        <p:style>
+          <a:lnRef idx="1">
+            <a:schemeClr val="accent1"/>
+          </a:lnRef>
+          <a:fillRef idx="3">
+            <a:schemeClr val="accent1"/>
+          </a:fillRef>
+          <a:effectRef idx="2">
+            <a:schemeClr val="accent1"/>
+          </a:effectRef>
+          <a:fontRef idx="minor">
+            <a:schemeClr val="lt1"/>
+          </a:fontRef>
+        </p:style>
+        <p:txBody>
+          <a:bodyPr rtlCol="0" anchor="ctr"/>
+          <a:lstStyle/>
+          <a:p>
+            <a:pPr algn="ctr"/>
+          </a:p>
+        </p:txBody>
+      </p:sp>
+      <p:sp>
+        <p:nvSpPr>
+          <p:cNvPr id="4" name="TextBox 3"/>
+          <p:cNvSpPr txBox="1"/>
+          <p:nvPr/>
+        </p:nvSpPr>
+        <p:spPr>
+          <a:xfrm>
+            <a:off x="822960" y="2011680"/>
+            <a:ext cx="10515600" cy="3200400"/>
+          </a:xfrm>
+          <a:prstGeom prst="rect">
+            <a:avLst/>
+          </a:prstGeom>
+          <a:noFill/>
+        </p:spPr>
+        <p:txBody>
+          <a:bodyPr wrap="square">
+            <a:spAutoFit/>
+          </a:bodyPr>
+          <a:lstStyle/>
+          <a:p>
+            <a:r>
+              <a:rPr sz="2800" b="0">
+                <a:solidFill>
+                  <a:srgbClr val="C5D2CC"/>
+                </a:solidFill>
+                <a:latin typeface="Arial"/>
+              </a:rPr>
+              <a:t>Everyone else ships a classifier.</a:t>
+            </a:r>
+          </a:p>
+          <a:p>
+            <a:r>
+              <a:rPr sz="4000" b="1">
+                <a:solidFill>
+                  <a:srgbClr val="FFFFFF"/>
+                </a:solidFill>
+                <a:latin typeface="Arial"/>
+              </a:rPr>
+              <a:t>We ship a twin.</a:t>
+            </a:r>
+          </a:p>
+          <a:p>
+            <a:r>
+              <a:rPr sz="1400" b="0">
+                <a:solidFill>
+                  <a:srgbClr val="FFFFFF"/>
+                </a:solidFill>
+                <a:latin typeface="Arial"/>
+              </a:rPr>
+              <a:t/>
+            </a:r>
+          </a:p>
+          <a:p>
+            <a:r>
+              <a:rPr sz="1800" b="0">
+                <a:solidFill>
+                  <a:srgbClr val="E6F5F2"/>
+                </a:solidFill>
+                <a:latin typeface="Arial"/>
+              </a:rPr>
+              <a:t>If the document tries to make your agent steal secrets,</a:t>
+            </a:r>
+          </a:p>
+          <a:p>
+            <a:r>
+              <a:rPr sz="1800" b="0">
+                <a:solidFill>
+                  <a:srgbClr val="E6F5F2"/>
+                </a:solidFill>
+                <a:latin typeface="Arial"/>
+              </a:rPr>
+              <a:t>the plans diverge — and Aegis blocks before a single tool runs.</a:t>
+            </a:r>
+          </a:p>
+        </p:txBody>
+      </p:sp>
+      <p:sp>
+        <p:nvSpPr>
+          <p:cNvPr id="5" name="TextBox 4"/>
+          <p:cNvSpPr txBox="1"/>
+          <p:nvPr/>
+        </p:nvSpPr>
+        <p:spPr>
+          <a:xfrm>
+            <a:off x="822960" y="5669280"/>
+            <a:ext cx="10515600" cy="640080"/>
+          </a:xfrm>
+          <a:prstGeom prst="rect">
+            <a:avLst/>
+          </a:prstGeom>
+          <a:noFill/>
+        </p:spPr>
+        <p:txBody>
+          <a:bodyPr wrap="none">
+            <a:spAutoFit/>
+          </a:bodyPr>
+          <a:lstStyle/>
+          <a:p>
+            <a:r>
+              <a:rPr sz="1600" b="1">
+                <a:solidFill>
+                  <a:srgbClr val="9AE6C5"/>
+                </a:solidFill>
+                <a:latin typeface="Arial"/>
+              </a:rPr>
+              <a:t>Live  ·  aegis-prompt-injection-firewall.vercel.app     ·     Thank you</a:t>
             </a:r>
           </a:p>
         </p:txBody>
@@ -3438,7 +4343,7 @@
                 </a:solidFill>
                 <a:latin typeface="Arial"/>
               </a:rPr>
-              <a:t>The enterprise risk</a:t>
+              <a:t>Problem statement</a:t>
             </a:r>
           </a:p>
         </p:txBody>
@@ -3945,7 +4850,7 @@
                 </a:solidFill>
                 <a:latin typeface="Arial"/>
               </a:rPr>
-              <a:t>Accenture clients are shipping copilots and agents into production workflows.</a:t>
+              <a:t>Enterprises are shipping copilots and agents into production workflows.</a:t>
             </a:r>
           </a:p>
           <a:p>
@@ -4168,7 +5073,7 @@
                 </a:solidFill>
                 <a:latin typeface="Arial"/>
               </a:rPr>
-              <a:t>The insight: runtime, not classification</a:t>
+              <a:t>Proposed solution — runtime twin, not classification</a:t>
             </a:r>
           </a:p>
         </p:txBody>
@@ -4207,39 +5112,7 @@
                 </a:solidFill>
                 <a:latin typeface="Arial"/>
               </a:rPr>
-              <a:t>Prompt injection is not a text-classification problem.</a:t>
-            </a:r>
-          </a:p>
-          <a:p>
-            <a:pPr>
-              <a:spcAft>
-                <a:spcPts val="800"/>
-              </a:spcAft>
-            </a:pPr>
-            <a:r>
-              <a:rPr sz="1700" b="0">
-                <a:solidFill>
-                  <a:srgbClr val="0B1F1A"/>
-                </a:solidFill>
-                <a:latin typeface="Arial"/>
-              </a:rPr>
-              <a:t/>
-            </a:r>
-          </a:p>
-          <a:p>
-            <a:pPr>
-              <a:spcAft>
-                <a:spcPts val="800"/>
-              </a:spcAft>
-            </a:pPr>
-            <a:r>
-              <a:rPr sz="1700" b="0">
-                <a:solidFill>
-                  <a:srgbClr val="0B1F1A"/>
-                </a:solidFill>
-                <a:latin typeface="Arial"/>
-              </a:rPr>
-              <a:t>It is a runtime security problem:</a:t>
+              <a:t>Prompt injection is a runtime security problem:</a:t>
             </a:r>
           </a:p>
           <a:p>
@@ -5717,7 +6590,7 @@
                 </a:solidFill>
                 <a:latin typeface="Arial"/>
               </a:rPr>
-              <a:t>Architecture — evidence for claims</a:t>
+              <a:t>Architecture</a:t>
             </a:r>
           </a:p>
         </p:txBody>
@@ -5820,7 +6693,7 @@
                 </a:solidFill>
                 <a:latin typeface="Arial"/>
               </a:rPr>
-              <a:t>Supporting controls (enterprise-ready):</a:t>
+              <a:t>Supporting controls:</a:t>
             </a:r>
           </a:p>
           <a:p>
@@ -5901,22 +6774,6 @@
                 <a:latin typeface="Arial"/>
               </a:rPr>
               <a:t/>
-            </a:r>
-          </a:p>
-          <a:p>
-            <a:pPr>
-              <a:spcAft>
-                <a:spcPts val="800"/>
-              </a:spcAft>
-            </a:pPr>
-            <a:r>
-              <a:rPr sz="1500" b="0">
-                <a:solidFill>
-                  <a:srgbClr val="0B1F1A"/>
-                </a:solidFill>
-                <a:latin typeface="Arial"/>
-              </a:rPr>
-              <a:t>Stack: Python · FastAPI · Streamlit (local) · Vercel production UI</a:t>
             </a:r>
           </a:p>
           <a:p>
@@ -6139,7 +6996,7 @@
                 </a:solidFill>
                 <a:latin typeface="Arial"/>
               </a:rPr>
-              <a:t>Demo proof</a:t>
+              <a:t>AI models &amp; technologies</a:t>
             </a:r>
           </a:p>
         </p:txBody>
@@ -6153,7 +7010,7 @@
         <p:spPr>
           <a:xfrm>
             <a:off x="640080" y="1234440"/>
-            <a:ext cx="10881360" cy="777240"/>
+            <a:ext cx="5486400" cy="4389120"/>
           </a:xfrm>
           <a:prstGeom prst="roundRect">
             <a:avLst/>
@@ -6191,14 +7048,57 @@
       </p:sp>
       <p:sp>
         <p:nvSpPr>
-          <p:cNvPr id="6" name="TextBox 5"/>
+          <p:cNvPr id="6" name="Rectangle 5"/>
+          <p:cNvSpPr/>
+          <p:nvPr/>
+        </p:nvSpPr>
+        <p:spPr>
+          <a:xfrm>
+            <a:off x="640080" y="1234440"/>
+            <a:ext cx="73152" cy="4389120"/>
+          </a:xfrm>
+          <a:prstGeom prst="rect">
+            <a:avLst/>
+          </a:prstGeom>
+          <a:solidFill>
+            <a:srgbClr val="0F766E"/>
+          </a:solidFill>
+          <a:ln>
+            <a:noFill/>
+          </a:ln>
+        </p:spPr>
+        <p:style>
+          <a:lnRef idx="1">
+            <a:schemeClr val="accent1"/>
+          </a:lnRef>
+          <a:fillRef idx="3">
+            <a:schemeClr val="accent1"/>
+          </a:fillRef>
+          <a:effectRef idx="2">
+            <a:schemeClr val="accent1"/>
+          </a:effectRef>
+          <a:fontRef idx="minor">
+            <a:schemeClr val="lt1"/>
+          </a:fontRef>
+        </p:style>
+        <p:txBody>
+          <a:bodyPr rtlCol="0" anchor="ctr"/>
+          <a:lstStyle/>
+          <a:p>
+            <a:pPr algn="ctr"/>
+          </a:p>
+        </p:txBody>
+      </p:sp>
+      <p:sp>
+        <p:nvSpPr>
+          <p:cNvPr id="7" name="TextBox 6"/>
           <p:cNvSpPr txBox="1"/>
           <p:nvPr/>
         </p:nvSpPr>
         <p:spPr>
           <a:xfrm>
-            <a:off x="868680" y="1399032"/>
-            <a:ext cx="5029200" cy="457200"/>
+            <a:off x="868680" y="1417320"/>
+            <a:ext cx="5120640" cy="365760"/>
           </a:xfrm>
           <a:prstGeom prst="rect">
             <a:avLst/>
@@ -6214,25 +7114,25 @@
             <a:r>
               <a:rPr sz="1400" b="1">
                 <a:solidFill>
-                  <a:srgbClr val="0B1F1A"/>
-                </a:solidFill>
-                <a:latin typeface="Arial"/>
-              </a:rPr>
-              <a:t>Benign product PDF</a:t>
-            </a:r>
-          </a:p>
-        </p:txBody>
-      </p:sp>
-      <p:sp>
-        <p:nvSpPr>
-          <p:cNvPr id="7" name="TextBox 6"/>
+                  <a:srgbClr val="115E59"/>
+                </a:solidFill>
+                <a:latin typeface="Arial"/>
+              </a:rPr>
+              <a:t>Agentic AI in the product</a:t>
+            </a:r>
+          </a:p>
+        </p:txBody>
+      </p:sp>
+      <p:sp>
+        <p:nvSpPr>
+          <p:cNvPr id="8" name="TextBox 7"/>
           <p:cNvSpPr txBox="1"/>
           <p:nvPr/>
         </p:nvSpPr>
         <p:spPr>
           <a:xfrm>
-            <a:off x="6035040" y="1399032"/>
-            <a:ext cx="2011680" cy="457200"/>
+            <a:off x="868680" y="1828800"/>
+            <a:ext cx="5120640" cy="3611879"/>
           </a:xfrm>
           <a:prstGeom prst="rect">
             <a:avLst/>
@@ -6240,53 +7140,23 @@
           <a:noFill/>
         </p:spPr>
         <p:txBody>
-          <a:bodyPr wrap="none">
+          <a:bodyPr wrap="square">
             <a:spAutoFit/>
           </a:bodyPr>
           <a:lstStyle/>
           <a:p>
             <a:r>
-              <a:rPr sz="1300" b="1">
-                <a:solidFill>
-                  <a:srgbClr val="047857"/>
-                </a:solidFill>
-                <a:latin typeface="Arial"/>
-              </a:rPr>
-              <a:t>ALLOW</a:t>
-            </a:r>
-          </a:p>
-        </p:txBody>
-      </p:sp>
-      <p:sp>
-        <p:nvSpPr>
-          <p:cNvPr id="8" name="TextBox 7"/>
-          <p:cNvSpPr txBox="1"/>
-          <p:nvPr/>
-        </p:nvSpPr>
-        <p:spPr>
-          <a:xfrm>
-            <a:off x="8046720" y="1399032"/>
-            <a:ext cx="3200400" cy="457200"/>
-          </a:xfrm>
-          <a:prstGeom prst="rect">
-            <a:avLst/>
-          </a:prstGeom>
-          <a:noFill/>
-        </p:spPr>
-        <p:txBody>
-          <a:bodyPr wrap="none">
-            <a:spAutoFit/>
-          </a:bodyPr>
-          <a:lstStyle/>
-          <a:p>
-            <a:r>
               <a:rPr sz="1200" b="0">
                 <a:solidFill>
                   <a:srgbClr val="5B6F68"/>
                 </a:solidFill>
                 <a:latin typeface="Arial"/>
               </a:rPr>
-              <a:t>Trusted summarize path</a:t>
+              <a:t>• Dual planner (trusted vs raw tool trajectories)
+• Deterministic offline planner by default — reproducible demos
+• Optional OpenAI-compatible / Ollama LLM planner enrichment
+• Protected agent executes only on ALLOW with capability tokens
+• Session memory for multi-step jailbreak escalation</a:t>
             </a:r>
           </a:p>
         </p:txBody>
@@ -6299,8 +7169,8 @@
         </p:nvSpPr>
         <p:spPr>
           <a:xfrm>
-            <a:off x="640080" y="2103120"/>
-            <a:ext cx="10881360" cy="777240"/>
+            <a:off x="6355080" y="1234440"/>
+            <a:ext cx="5120640" cy="4389120"/>
           </a:xfrm>
           <a:prstGeom prst="roundRect">
             <a:avLst/>
@@ -6338,127 +7208,23 @@
       </p:sp>
       <p:sp>
         <p:nvSpPr>
-          <p:cNvPr id="10" name="TextBox 9"/>
-          <p:cNvSpPr txBox="1"/>
-          <p:nvPr/>
-        </p:nvSpPr>
-        <p:spPr>
-          <a:xfrm>
-            <a:off x="868680" y="2267712"/>
-            <a:ext cx="5029200" cy="457200"/>
-          </a:xfrm>
-          <a:prstGeom prst="rect">
-            <a:avLst/>
-          </a:prstGeom>
-          <a:noFill/>
-        </p:spPr>
-        <p:txBody>
-          <a:bodyPr wrap="none">
-            <a:spAutoFit/>
-          </a:bodyPr>
-          <a:lstStyle/>
-          <a:p>
-            <a:r>
-              <a:rPr sz="1400" b="1">
-                <a:solidFill>
-                  <a:srgbClr val="0B1F1A"/>
-                </a:solidFill>
-                <a:latin typeface="Arial"/>
-              </a:rPr>
-              <a:t>Indirect injection in PDF</a:t>
-            </a:r>
-          </a:p>
-        </p:txBody>
-      </p:sp>
-      <p:sp>
-        <p:nvSpPr>
-          <p:cNvPr id="11" name="TextBox 10"/>
-          <p:cNvSpPr txBox="1"/>
-          <p:nvPr/>
-        </p:nvSpPr>
-        <p:spPr>
-          <a:xfrm>
-            <a:off x="6035040" y="2267712"/>
-            <a:ext cx="2011680" cy="457200"/>
-          </a:xfrm>
-          <a:prstGeom prst="rect">
-            <a:avLst/>
-          </a:prstGeom>
-          <a:noFill/>
-        </p:spPr>
-        <p:txBody>
-          <a:bodyPr wrap="none">
-            <a:spAutoFit/>
-          </a:bodyPr>
-          <a:lstStyle/>
-          <a:p>
-            <a:r>
-              <a:rPr sz="1300" b="1">
-                <a:solidFill>
-                  <a:srgbClr val="B91C1C"/>
-                </a:solidFill>
-                <a:latin typeface="Arial"/>
-              </a:rPr>
-              <a:t>BLOCK</a:t>
-            </a:r>
-          </a:p>
-        </p:txBody>
-      </p:sp>
-      <p:sp>
-        <p:nvSpPr>
-          <p:cNvPr id="12" name="TextBox 11"/>
-          <p:cNvSpPr txBox="1"/>
-          <p:nvPr/>
-        </p:nvSpPr>
-        <p:spPr>
-          <a:xfrm>
-            <a:off x="8046720" y="2267712"/>
-            <a:ext cx="3200400" cy="457200"/>
-          </a:xfrm>
-          <a:prstGeom prst="rect">
-            <a:avLst/>
-          </a:prstGeom>
-          <a:noFill/>
-        </p:spPr>
-        <p:txBody>
-          <a:bodyPr wrap="none">
-            <a:spAutoFit/>
-          </a:bodyPr>
-          <a:lstStyle/>
-          <a:p>
-            <a:r>
-              <a:rPr sz="1200" b="0">
-                <a:solidFill>
-                  <a:srgbClr val="5B6F68"/>
-                </a:solidFill>
-                <a:latin typeface="Arial"/>
-              </a:rPr>
-              <a:t>Twin drift: get_secret + send_email</a:t>
-            </a:r>
-          </a:p>
-        </p:txBody>
-      </p:sp>
-      <p:sp>
-        <p:nvSpPr>
-          <p:cNvPr id="13" name="Rounded Rectangle 12"/>
+          <p:cNvPr id="10" name="Rectangle 9"/>
           <p:cNvSpPr/>
           <p:nvPr/>
         </p:nvSpPr>
         <p:spPr>
           <a:xfrm>
-            <a:off x="640080" y="2971800"/>
-            <a:ext cx="10881360" cy="777240"/>
-          </a:xfrm>
-          <a:prstGeom prst="roundRect">
+            <a:off x="6355080" y="1234440"/>
+            <a:ext cx="73152" cy="4389120"/>
+          </a:xfrm>
+          <a:prstGeom prst="rect">
             <a:avLst/>
           </a:prstGeom>
           <a:solidFill>
-            <a:srgbClr val="FFFFFF"/>
+            <a:srgbClr val="0F766E"/>
           </a:solidFill>
           <a:ln>
-            <a:solidFill>
-              <a:srgbClr val="D9E2DE"/>
-            </a:solidFill>
+            <a:noFill/>
           </a:ln>
         </p:spPr>
         <p:style>
@@ -6485,14 +7251,14 @@
       </p:sp>
       <p:sp>
         <p:nvSpPr>
-          <p:cNvPr id="14" name="TextBox 13"/>
+          <p:cNvPr id="11" name="TextBox 10"/>
           <p:cNvSpPr txBox="1"/>
           <p:nvPr/>
         </p:nvSpPr>
         <p:spPr>
           <a:xfrm>
-            <a:off x="868680" y="3136392"/>
-            <a:ext cx="5029200" cy="457200"/>
+            <a:off x="6583680" y="1417320"/>
+            <a:ext cx="4754879" cy="365760"/>
           </a:xfrm>
           <a:prstGeom prst="rect">
             <a:avLst/>
@@ -6508,25 +7274,63 @@
             <a:r>
               <a:rPr sz="1400" b="1">
                 <a:solidFill>
-                  <a:srgbClr val="0B1F1A"/>
-                </a:solidFill>
-                <a:latin typeface="Arial"/>
-              </a:rPr>
-              <a:t>Encoded HTML jailbreak</a:t>
-            </a:r>
-          </a:p>
-        </p:txBody>
-      </p:sp>
-      <p:sp>
-        <p:nvSpPr>
-          <p:cNvPr id="15" name="TextBox 14"/>
+                  <a:srgbClr val="115E59"/>
+                </a:solidFill>
+                <a:latin typeface="Arial"/>
+              </a:rPr>
+              <a:t>Engineering stack</a:t>
+            </a:r>
+          </a:p>
+        </p:txBody>
+      </p:sp>
+      <p:sp>
+        <p:nvSpPr>
+          <p:cNvPr id="12" name="TextBox 11"/>
           <p:cNvSpPr txBox="1"/>
           <p:nvPr/>
         </p:nvSpPr>
         <p:spPr>
           <a:xfrm>
-            <a:off x="6035040" y="3136392"/>
-            <a:ext cx="2011680" cy="457200"/>
+            <a:off x="6583680" y="1828800"/>
+            <a:ext cx="4754879" cy="3611879"/>
+          </a:xfrm>
+          <a:prstGeom prst="rect">
+            <a:avLst/>
+          </a:prstGeom>
+          <a:noFill/>
+        </p:spPr>
+        <p:txBody>
+          <a:bodyPr wrap="square">
+            <a:spAutoFit/>
+          </a:bodyPr>
+          <a:lstStyle/>
+          <a:p>
+            <a:r>
+              <a:rPr sz="1200" b="0">
+                <a:solidFill>
+                  <a:srgbClr val="5B6F68"/>
+                </a:solidFill>
+                <a:latin typeface="Arial"/>
+              </a:rPr>
+              <a:t>• Python 3.11 · FastAPI · Pydantic v2
+• Streamlit analyst console (local)
+• Vercel Executive Console (production)
+• pypdf · BeautifulSoup · Pillow (+ optional Tesseract OCR)
+• SQLite audit · pytest · 55-sample corpus</a:t>
+            </a:r>
+          </a:p>
+        </p:txBody>
+      </p:sp>
+      <p:sp>
+        <p:nvSpPr>
+          <p:cNvPr id="13" name="TextBox 12"/>
+          <p:cNvSpPr txBox="1"/>
+          <p:nvPr/>
+        </p:nvSpPr>
+        <p:spPr>
+          <a:xfrm>
+            <a:off x="548640" y="6446520"/>
+            <a:ext cx="9144000" cy="274320"/>
           </a:xfrm>
           <a:prstGeom prst="rect">
             <a:avLst/>
@@ -6540,374 +7344,12 @@
           <a:lstStyle/>
           <a:p>
             <a:r>
-              <a:rPr sz="1300" b="1">
-                <a:solidFill>
-                  <a:srgbClr val="B91C1C"/>
-                </a:solidFill>
-                <a:latin typeface="Arial"/>
-              </a:rPr>
-              <a:t>BLOCK</a:t>
-            </a:r>
-          </a:p>
-        </p:txBody>
-      </p:sp>
-      <p:sp>
-        <p:nvSpPr>
-          <p:cNvPr id="16" name="TextBox 15"/>
-          <p:cNvSpPr txBox="1"/>
-          <p:nvPr/>
-        </p:nvSpPr>
-        <p:spPr>
-          <a:xfrm>
-            <a:off x="8046720" y="3136392"/>
-            <a:ext cx="3200400" cy="457200"/>
-          </a:xfrm>
-          <a:prstGeom prst="rect">
-            <a:avLst/>
-          </a:prstGeom>
-          <a:noFill/>
-        </p:spPr>
-        <p:txBody>
-          <a:bodyPr wrap="none">
-            <a:spAutoFit/>
-          </a:bodyPr>
-          <a:lstStyle/>
-          <a:p>
-            <a:r>
-              <a:rPr sz="1200" b="0">
+              <a:rPr sz="1000" b="0">
                 <a:solidFill>
                   <a:srgbClr val="5B6F68"/>
                 </a:solidFill>
                 <a:latin typeface="Arial"/>
               </a:rPr>
-              <a:t>Decode layer + override</a:t>
-            </a:r>
-          </a:p>
-        </p:txBody>
-      </p:sp>
-      <p:sp>
-        <p:nvSpPr>
-          <p:cNvPr id="17" name="Rounded Rectangle 16"/>
-          <p:cNvSpPr/>
-          <p:nvPr/>
-        </p:nvSpPr>
-        <p:spPr>
-          <a:xfrm>
-            <a:off x="640080" y="3840480"/>
-            <a:ext cx="10881360" cy="777240"/>
-          </a:xfrm>
-          <a:prstGeom prst="roundRect">
-            <a:avLst/>
-          </a:prstGeom>
-          <a:solidFill>
-            <a:srgbClr val="FFFFFF"/>
-          </a:solidFill>
-          <a:ln>
-            <a:solidFill>
-              <a:srgbClr val="D9E2DE"/>
-            </a:solidFill>
-          </a:ln>
-        </p:spPr>
-        <p:style>
-          <a:lnRef idx="1">
-            <a:schemeClr val="accent1"/>
-          </a:lnRef>
-          <a:fillRef idx="3">
-            <a:schemeClr val="accent1"/>
-          </a:fillRef>
-          <a:effectRef idx="2">
-            <a:schemeClr val="accent1"/>
-          </a:effectRef>
-          <a:fontRef idx="minor">
-            <a:schemeClr val="lt1"/>
-          </a:fontRef>
-        </p:style>
-        <p:txBody>
-          <a:bodyPr rtlCol="0" anchor="ctr"/>
-          <a:lstStyle/>
-          <a:p>
-            <a:pPr algn="ctr"/>
-          </a:p>
-        </p:txBody>
-      </p:sp>
-      <p:sp>
-        <p:nvSpPr>
-          <p:cNvPr id="18" name="TextBox 17"/>
-          <p:cNvSpPr txBox="1"/>
-          <p:nvPr/>
-        </p:nvSpPr>
-        <p:spPr>
-          <a:xfrm>
-            <a:off x="868680" y="4005072"/>
-            <a:ext cx="5029200" cy="457200"/>
-          </a:xfrm>
-          <a:prstGeom prst="rect">
-            <a:avLst/>
-          </a:prstGeom>
-          <a:noFill/>
-        </p:spPr>
-        <p:txBody>
-          <a:bodyPr wrap="none">
-            <a:spAutoFit/>
-          </a:bodyPr>
-          <a:lstStyle/>
-          <a:p>
-            <a:r>
-              <a:rPr sz="1400" b="1">
-                <a:solidFill>
-                  <a:srgbClr val="0B1F1A"/>
-                </a:solidFill>
-                <a:latin typeface="Arial"/>
-              </a:rPr>
-              <a:t>Multi-step roleplay → tools</a:t>
-            </a:r>
-          </a:p>
-        </p:txBody>
-      </p:sp>
-      <p:sp>
-        <p:nvSpPr>
-          <p:cNvPr id="19" name="TextBox 18"/>
-          <p:cNvSpPr txBox="1"/>
-          <p:nvPr/>
-        </p:nvSpPr>
-        <p:spPr>
-          <a:xfrm>
-            <a:off x="6035040" y="4005072"/>
-            <a:ext cx="2011680" cy="457200"/>
-          </a:xfrm>
-          <a:prstGeom prst="rect">
-            <a:avLst/>
-          </a:prstGeom>
-          <a:noFill/>
-        </p:spPr>
-        <p:txBody>
-          <a:bodyPr wrap="none">
-            <a:spAutoFit/>
-          </a:bodyPr>
-          <a:lstStyle/>
-          <a:p>
-            <a:r>
-              <a:rPr sz="1300" b="1">
-                <a:solidFill>
-                  <a:srgbClr val="B91C1C"/>
-                </a:solidFill>
-                <a:latin typeface="Arial"/>
-              </a:rPr>
-              <a:t>QUARANTINE / BLOCK</a:t>
-            </a:r>
-          </a:p>
-        </p:txBody>
-      </p:sp>
-      <p:sp>
-        <p:nvSpPr>
-          <p:cNvPr id="20" name="TextBox 19"/>
-          <p:cNvSpPr txBox="1"/>
-          <p:nvPr/>
-        </p:nvSpPr>
-        <p:spPr>
-          <a:xfrm>
-            <a:off x="8046720" y="4005072"/>
-            <a:ext cx="3200400" cy="457200"/>
-          </a:xfrm>
-          <a:prstGeom prst="rect">
-            <a:avLst/>
-          </a:prstGeom>
-          <a:noFill/>
-        </p:spPr>
-        <p:txBody>
-          <a:bodyPr wrap="none">
-            <a:spAutoFit/>
-          </a:bodyPr>
-          <a:lstStyle/>
-          <a:p>
-            <a:r>
-              <a:rPr sz="1200" b="0">
-                <a:solidFill>
-                  <a:srgbClr val="5B6F68"/>
-                </a:solidFill>
-                <a:latin typeface="Arial"/>
-              </a:rPr>
-              <a:t>Session risk escalation</a:t>
-            </a:r>
-          </a:p>
-        </p:txBody>
-      </p:sp>
-      <p:sp>
-        <p:nvSpPr>
-          <p:cNvPr id="21" name="Rounded Rectangle 20"/>
-          <p:cNvSpPr/>
-          <p:nvPr/>
-        </p:nvSpPr>
-        <p:spPr>
-          <a:xfrm>
-            <a:off x="640080" y="4709160"/>
-            <a:ext cx="10881360" cy="777240"/>
-          </a:xfrm>
-          <a:prstGeom prst="roundRect">
-            <a:avLst/>
-          </a:prstGeom>
-          <a:solidFill>
-            <a:srgbClr val="FFFFFF"/>
-          </a:solidFill>
-          <a:ln>
-            <a:solidFill>
-              <a:srgbClr val="D9E2DE"/>
-            </a:solidFill>
-          </a:ln>
-        </p:spPr>
-        <p:style>
-          <a:lnRef idx="1">
-            <a:schemeClr val="accent1"/>
-          </a:lnRef>
-          <a:fillRef idx="3">
-            <a:schemeClr val="accent1"/>
-          </a:fillRef>
-          <a:effectRef idx="2">
-            <a:schemeClr val="accent1"/>
-          </a:effectRef>
-          <a:fontRef idx="minor">
-            <a:schemeClr val="lt1"/>
-          </a:fontRef>
-        </p:style>
-        <p:txBody>
-          <a:bodyPr rtlCol="0" anchor="ctr"/>
-          <a:lstStyle/>
-          <a:p>
-            <a:pPr algn="ctr"/>
-          </a:p>
-        </p:txBody>
-      </p:sp>
-      <p:sp>
-        <p:nvSpPr>
-          <p:cNvPr id="22" name="TextBox 21"/>
-          <p:cNvSpPr txBox="1"/>
-          <p:nvPr/>
-        </p:nvSpPr>
-        <p:spPr>
-          <a:xfrm>
-            <a:off x="868680" y="4873752"/>
-            <a:ext cx="5029200" cy="457200"/>
-          </a:xfrm>
-          <a:prstGeom prst="rect">
-            <a:avLst/>
-          </a:prstGeom>
-          <a:noFill/>
-        </p:spPr>
-        <p:txBody>
-          <a:bodyPr wrap="none">
-            <a:spAutoFit/>
-          </a:bodyPr>
-          <a:lstStyle/>
-          <a:p>
-            <a:r>
-              <a:rPr sz="1400" b="1">
-                <a:solidFill>
-                  <a:srgbClr val="0B1F1A"/>
-                </a:solidFill>
-                <a:latin typeface="Arial"/>
-              </a:rPr>
-              <a:t>Human analyst queue</a:t>
-            </a:r>
-          </a:p>
-        </p:txBody>
-      </p:sp>
-      <p:sp>
-        <p:nvSpPr>
-          <p:cNvPr id="23" name="TextBox 22"/>
-          <p:cNvSpPr txBox="1"/>
-          <p:nvPr/>
-        </p:nvSpPr>
-        <p:spPr>
-          <a:xfrm>
-            <a:off x="6035040" y="4873752"/>
-            <a:ext cx="2011680" cy="457200"/>
-          </a:xfrm>
-          <a:prstGeom prst="rect">
-            <a:avLst/>
-          </a:prstGeom>
-          <a:noFill/>
-        </p:spPr>
-        <p:txBody>
-          <a:bodyPr wrap="none">
-            <a:spAutoFit/>
-          </a:bodyPr>
-          <a:lstStyle/>
-          <a:p>
-            <a:r>
-              <a:rPr sz="1300" b="1">
-                <a:solidFill>
-                  <a:srgbClr val="0F766E"/>
-                </a:solidFill>
-                <a:latin typeface="Arial"/>
-              </a:rPr>
-              <a:t>HITL</a:t>
-            </a:r>
-          </a:p>
-        </p:txBody>
-      </p:sp>
-      <p:sp>
-        <p:nvSpPr>
-          <p:cNvPr id="24" name="TextBox 23"/>
-          <p:cNvSpPr txBox="1"/>
-          <p:nvPr/>
-        </p:nvSpPr>
-        <p:spPr>
-          <a:xfrm>
-            <a:off x="8046720" y="4873752"/>
-            <a:ext cx="3200400" cy="457200"/>
-          </a:xfrm>
-          <a:prstGeom prst="rect">
-            <a:avLst/>
-          </a:prstGeom>
-          <a:noFill/>
-        </p:spPr>
-        <p:txBody>
-          <a:bodyPr wrap="none">
-            <a:spAutoFit/>
-          </a:bodyPr>
-          <a:lstStyle/>
-          <a:p>
-            <a:r>
-              <a:rPr sz="1200" b="0">
-                <a:solidFill>
-                  <a:srgbClr val="5B6F68"/>
-                </a:solidFill>
-                <a:latin typeface="Arial"/>
-              </a:rPr>
-              <a:t>Approve / deny with audit note</a:t>
-            </a:r>
-          </a:p>
-        </p:txBody>
-      </p:sp>
-      <p:sp>
-        <p:nvSpPr>
-          <p:cNvPr id="25" name="TextBox 24"/>
-          <p:cNvSpPr txBox="1"/>
-          <p:nvPr/>
-        </p:nvSpPr>
-        <p:spPr>
-          <a:xfrm>
-            <a:off x="548640" y="6446520"/>
-            <a:ext cx="9144000" cy="274320"/>
-          </a:xfrm>
-          <a:prstGeom prst="rect">
-            <a:avLst/>
-          </a:prstGeom>
-          <a:noFill/>
-        </p:spPr>
-        <p:txBody>
-          <a:bodyPr wrap="none">
-            <a:spAutoFit/>
-          </a:bodyPr>
-          <a:lstStyle/>
-          <a:p>
-            <a:r>
-              <a:rPr sz="1000" b="0">
-                <a:solidFill>
-                  <a:srgbClr val="5B6F68"/>
-                </a:solidFill>
-                <a:latin typeface="Arial"/>
-              </a:rPr>
               <a:t>Aegis Guard  ·  ET AI Hackathon Problem 2  ·  Claim F3 / D2  ·  06</a:t>
             </a:r>
           </a:p>
@@ -6915,7 +7357,7 @@
       </p:sp>
       <p:sp>
         <p:nvSpPr>
-          <p:cNvPr id="26" name="TextBox 25"/>
+          <p:cNvPr id="14" name="TextBox 13"/>
           <p:cNvSpPr txBox="1"/>
           <p:nvPr/>
         </p:nvSpPr>
@@ -7081,7 +7523,7 @@
                 </a:solidFill>
                 <a:latin typeface="Arial"/>
               </a:rPr>
-              <a:t>9-blocker claim — F3 / D2</a:t>
+              <a:t>Product demo — proof points</a:t>
             </a:r>
           </a:p>
         </p:txBody>
@@ -7095,7 +7537,7 @@
         <p:spPr>
           <a:xfrm>
             <a:off x="640080" y="1234440"/>
-            <a:ext cx="5486400" cy="4206240"/>
+            <a:ext cx="10881360" cy="777240"/>
           </a:xfrm>
           <a:prstGeom prst="roundRect">
             <a:avLst/>
@@ -7133,57 +7575,14 @@
       </p:sp>
       <p:sp>
         <p:nvSpPr>
-          <p:cNvPr id="6" name="Rectangle 5"/>
-          <p:cNvSpPr/>
-          <p:nvPr/>
-        </p:nvSpPr>
-        <p:spPr>
-          <a:xfrm>
-            <a:off x="640080" y="1234440"/>
-            <a:ext cx="73152" cy="4206240"/>
-          </a:xfrm>
-          <a:prstGeom prst="rect">
-            <a:avLst/>
-          </a:prstGeom>
-          <a:solidFill>
-            <a:srgbClr val="0F766E"/>
-          </a:solidFill>
-          <a:ln>
-            <a:noFill/>
-          </a:ln>
-        </p:spPr>
-        <p:style>
-          <a:lnRef idx="1">
-            <a:schemeClr val="accent1"/>
-          </a:lnRef>
-          <a:fillRef idx="3">
-            <a:schemeClr val="accent1"/>
-          </a:fillRef>
-          <a:effectRef idx="2">
-            <a:schemeClr val="accent1"/>
-          </a:effectRef>
-          <a:fontRef idx="minor">
-            <a:schemeClr val="lt1"/>
-          </a:fontRef>
-        </p:style>
-        <p:txBody>
-          <a:bodyPr rtlCol="0" anchor="ctr"/>
-          <a:lstStyle/>
-          <a:p>
-            <a:pPr algn="ctr"/>
-          </a:p>
-        </p:txBody>
-      </p:sp>
-      <p:sp>
-        <p:nvSpPr>
-          <p:cNvPr id="7" name="TextBox 6"/>
+          <p:cNvPr id="6" name="TextBox 5"/>
           <p:cNvSpPr txBox="1"/>
           <p:nvPr/>
         </p:nvSpPr>
         <p:spPr>
           <a:xfrm>
-            <a:off x="868680" y="1417320"/>
-            <a:ext cx="5120640" cy="365760"/>
+            <a:off x="868680" y="1399032"/>
+            <a:ext cx="5029200" cy="457200"/>
           </a:xfrm>
           <a:prstGeom prst="rect">
             <a:avLst/>
@@ -7199,11 +7598,45 @@
             <a:r>
               <a:rPr sz="1400" b="1">
                 <a:solidFill>
-                  <a:srgbClr val="115E59"/>
-                </a:solidFill>
-                <a:latin typeface="Arial"/>
-              </a:rPr>
-              <a:t>F3 — Features (≥7 attack types)</a:t>
+                  <a:srgbClr val="0B1F1A"/>
+                </a:solidFill>
+                <a:latin typeface="Arial"/>
+              </a:rPr>
+              <a:t>Benign product PDF</a:t>
+            </a:r>
+          </a:p>
+        </p:txBody>
+      </p:sp>
+      <p:sp>
+        <p:nvSpPr>
+          <p:cNvPr id="7" name="TextBox 6"/>
+          <p:cNvSpPr txBox="1"/>
+          <p:nvPr/>
+        </p:nvSpPr>
+        <p:spPr>
+          <a:xfrm>
+            <a:off x="6035040" y="1399032"/>
+            <a:ext cx="2011680" cy="457200"/>
+          </a:xfrm>
+          <a:prstGeom prst="rect">
+            <a:avLst/>
+          </a:prstGeom>
+          <a:noFill/>
+        </p:spPr>
+        <p:txBody>
+          <a:bodyPr wrap="none">
+            <a:spAutoFit/>
+          </a:bodyPr>
+          <a:lstStyle/>
+          <a:p>
+            <a:r>
+              <a:rPr sz="1300" b="1">
+                <a:solidFill>
+                  <a:srgbClr val="047857"/>
+                </a:solidFill>
+                <a:latin typeface="Arial"/>
+              </a:rPr>
+              <a:t>ALLOW</a:t>
             </a:r>
           </a:p>
         </p:txBody>
@@ -7216,8 +7649,8 @@
         </p:nvSpPr>
         <p:spPr>
           <a:xfrm>
-            <a:off x="868680" y="1828800"/>
-            <a:ext cx="5120640" cy="3428999"/>
+            <a:off x="8046720" y="1399032"/>
+            <a:ext cx="3200400" cy="457200"/>
           </a:xfrm>
           <a:prstGeom prst="rect">
             <a:avLst/>
@@ -7225,7 +7658,7 @@
           <a:noFill/>
         </p:spPr>
         <p:txBody>
-          <a:bodyPr wrap="square">
+          <a:bodyPr wrap="none">
             <a:spAutoFit/>
           </a:bodyPr>
           <a:lstStyle/>
@@ -7237,17 +7670,7 @@
                 </a:solidFill>
                 <a:latin typeface="Arial"/>
               </a:rPr>
-              <a:t>All 9 official attack types implemented and covered in corpus:
-1 Instruction Override
-2 Role Change
-3 Secret Extraction
-4 Tool Abuse
-5 Credential Theft
-6 Context Poisoning
-7 Multi-Step Jailbreak
-8 Encoded Instructions
-9 Indirect Prompt Injection
-Live demo demonstrates ≥7 clearly.</a:t>
+              <a:t>Trusted summarize path</a:t>
             </a:r>
           </a:p>
         </p:txBody>
@@ -7260,8 +7683,8 @@
         </p:nvSpPr>
         <p:spPr>
           <a:xfrm>
-            <a:off x="6355080" y="1234440"/>
-            <a:ext cx="5120640" cy="4206240"/>
+            <a:off x="640080" y="2103120"/>
+            <a:ext cx="10881360" cy="777240"/>
           </a:xfrm>
           <a:prstGeom prst="roundRect">
             <a:avLst/>
@@ -7299,23 +7722,127 @@
       </p:sp>
       <p:sp>
         <p:nvSpPr>
-          <p:cNvPr id="10" name="Rectangle 9"/>
+          <p:cNvPr id="10" name="TextBox 9"/>
+          <p:cNvSpPr txBox="1"/>
+          <p:nvPr/>
+        </p:nvSpPr>
+        <p:spPr>
+          <a:xfrm>
+            <a:off x="868680" y="2267712"/>
+            <a:ext cx="5029200" cy="457200"/>
+          </a:xfrm>
+          <a:prstGeom prst="rect">
+            <a:avLst/>
+          </a:prstGeom>
+          <a:noFill/>
+        </p:spPr>
+        <p:txBody>
+          <a:bodyPr wrap="none">
+            <a:spAutoFit/>
+          </a:bodyPr>
+          <a:lstStyle/>
+          <a:p>
+            <a:r>
+              <a:rPr sz="1400" b="1">
+                <a:solidFill>
+                  <a:srgbClr val="0B1F1A"/>
+                </a:solidFill>
+                <a:latin typeface="Arial"/>
+              </a:rPr>
+              <a:t>Indirect injection in PDF</a:t>
+            </a:r>
+          </a:p>
+        </p:txBody>
+      </p:sp>
+      <p:sp>
+        <p:nvSpPr>
+          <p:cNvPr id="11" name="TextBox 10"/>
+          <p:cNvSpPr txBox="1"/>
+          <p:nvPr/>
+        </p:nvSpPr>
+        <p:spPr>
+          <a:xfrm>
+            <a:off x="6035040" y="2267712"/>
+            <a:ext cx="2011680" cy="457200"/>
+          </a:xfrm>
+          <a:prstGeom prst="rect">
+            <a:avLst/>
+          </a:prstGeom>
+          <a:noFill/>
+        </p:spPr>
+        <p:txBody>
+          <a:bodyPr wrap="none">
+            <a:spAutoFit/>
+          </a:bodyPr>
+          <a:lstStyle/>
+          <a:p>
+            <a:r>
+              <a:rPr sz="1300" b="1">
+                <a:solidFill>
+                  <a:srgbClr val="B91C1C"/>
+                </a:solidFill>
+                <a:latin typeface="Arial"/>
+              </a:rPr>
+              <a:t>BLOCK</a:t>
+            </a:r>
+          </a:p>
+        </p:txBody>
+      </p:sp>
+      <p:sp>
+        <p:nvSpPr>
+          <p:cNvPr id="12" name="TextBox 11"/>
+          <p:cNvSpPr txBox="1"/>
+          <p:nvPr/>
+        </p:nvSpPr>
+        <p:spPr>
+          <a:xfrm>
+            <a:off x="8046720" y="2267712"/>
+            <a:ext cx="3200400" cy="457200"/>
+          </a:xfrm>
+          <a:prstGeom prst="rect">
+            <a:avLst/>
+          </a:prstGeom>
+          <a:noFill/>
+        </p:spPr>
+        <p:txBody>
+          <a:bodyPr wrap="none">
+            <a:spAutoFit/>
+          </a:bodyPr>
+          <a:lstStyle/>
+          <a:p>
+            <a:r>
+              <a:rPr sz="1200" b="0">
+                <a:solidFill>
+                  <a:srgbClr val="5B6F68"/>
+                </a:solidFill>
+                <a:latin typeface="Arial"/>
+              </a:rPr>
+              <a:t>Twin drift: get_secret + send_email</a:t>
+            </a:r>
+          </a:p>
+        </p:txBody>
+      </p:sp>
+      <p:sp>
+        <p:nvSpPr>
+          <p:cNvPr id="13" name="Rounded Rectangle 12"/>
           <p:cNvSpPr/>
           <p:nvPr/>
         </p:nvSpPr>
         <p:spPr>
           <a:xfrm>
-            <a:off x="6355080" y="1234440"/>
-            <a:ext cx="73152" cy="4206240"/>
-          </a:xfrm>
-          <a:prstGeom prst="rect">
+            <a:off x="640080" y="2971800"/>
+            <a:ext cx="10881360" cy="777240"/>
+          </a:xfrm>
+          <a:prstGeom prst="roundRect">
             <a:avLst/>
           </a:prstGeom>
           <a:solidFill>
-            <a:srgbClr val="0F766E"/>
+            <a:srgbClr val="FFFFFF"/>
           </a:solidFill>
           <a:ln>
-            <a:noFill/>
+            <a:solidFill>
+              <a:srgbClr val="D9E2DE"/>
+            </a:solidFill>
           </a:ln>
         </p:spPr>
         <p:style>
@@ -7342,14 +7869,14 @@
       </p:sp>
       <p:sp>
         <p:nvSpPr>
-          <p:cNvPr id="11" name="TextBox 10"/>
+          <p:cNvPr id="14" name="TextBox 13"/>
           <p:cNvSpPr txBox="1"/>
           <p:nvPr/>
         </p:nvSpPr>
         <p:spPr>
           <a:xfrm>
-            <a:off x="6583680" y="1417320"/>
-            <a:ext cx="4754879" cy="365760"/>
+            <a:off x="868680" y="3136392"/>
+            <a:ext cx="5029200" cy="457200"/>
           </a:xfrm>
           <a:prstGeom prst="rect">
             <a:avLst/>
@@ -7365,64 +7892,25 @@
             <a:r>
               <a:rPr sz="1400" b="1">
                 <a:solidFill>
-                  <a:srgbClr val="115E59"/>
-                </a:solidFill>
-                <a:latin typeface="Arial"/>
-              </a:rPr>
-              <a:t>D2 — Depth (high reliability)</a:t>
-            </a:r>
-          </a:p>
-        </p:txBody>
-      </p:sp>
-      <p:sp>
-        <p:nvSpPr>
-          <p:cNvPr id="12" name="TextBox 11"/>
+                  <a:srgbClr val="0B1F1A"/>
+                </a:solidFill>
+                <a:latin typeface="Arial"/>
+              </a:rPr>
+              <a:t>Encoded HTML jailbreak</a:t>
+            </a:r>
+          </a:p>
+        </p:txBody>
+      </p:sp>
+      <p:sp>
+        <p:nvSpPr>
+          <p:cNvPr id="15" name="TextBox 14"/>
           <p:cNvSpPr txBox="1"/>
           <p:nvPr/>
         </p:nvSpPr>
         <p:spPr>
           <a:xfrm>
-            <a:off x="6583680" y="1828800"/>
-            <a:ext cx="4754879" cy="3428999"/>
-          </a:xfrm>
-          <a:prstGeom prst="rect">
-            <a:avLst/>
-          </a:prstGeom>
-          <a:noFill/>
-        </p:spPr>
-        <p:txBody>
-          <a:bodyPr wrap="square">
-            <a:spAutoFit/>
-          </a:bodyPr>
-          <a:lstStyle/>
-          <a:p>
-            <a:r>
-              <a:rPr sz="1200" b="0">
-                <a:solidFill>
-                  <a:srgbClr val="5B6F68"/>
-                </a:solidFill>
-                <a:latin typeface="Arial"/>
-              </a:rPr>
-              <a:t>Mostly structured/textual multimodal inputs (user, PDF text, HTML, email, API, OCR text) with demonstrable reliability:
-• Corpus n = 55
-• Precision / Recall / F1 ≈ 1.0 on suite
-• Pytest: 11/11 passed
-• Command Center metrics in live UI
-Not claiming D3: Word/image OCR not fully shown in production demo.</a:t>
-            </a:r>
-          </a:p>
-        </p:txBody>
-      </p:sp>
-      <p:sp>
-        <p:nvSpPr>
-          <p:cNvPr id="13" name="TextBox 12"/>
-          <p:cNvSpPr txBox="1"/>
-          <p:nvPr/>
-        </p:nvSpPr>
-        <p:spPr>
-          <a:xfrm>
-            <a:off x="548640" y="6446520"/>
-            <a:ext cx="9144000" cy="274320"/>
+            <a:off x="6035040" y="3136392"/>
+            <a:ext cx="2011680" cy="457200"/>
           </a:xfrm>
           <a:prstGeom prst="rect">
             <a:avLst/>
@@ -7436,6 +7924,368 @@
           <a:lstStyle/>
           <a:p>
             <a:r>
+              <a:rPr sz="1300" b="1">
+                <a:solidFill>
+                  <a:srgbClr val="B91C1C"/>
+                </a:solidFill>
+                <a:latin typeface="Arial"/>
+              </a:rPr>
+              <a:t>BLOCK</a:t>
+            </a:r>
+          </a:p>
+        </p:txBody>
+      </p:sp>
+      <p:sp>
+        <p:nvSpPr>
+          <p:cNvPr id="16" name="TextBox 15"/>
+          <p:cNvSpPr txBox="1"/>
+          <p:nvPr/>
+        </p:nvSpPr>
+        <p:spPr>
+          <a:xfrm>
+            <a:off x="8046720" y="3136392"/>
+            <a:ext cx="3200400" cy="457200"/>
+          </a:xfrm>
+          <a:prstGeom prst="rect">
+            <a:avLst/>
+          </a:prstGeom>
+          <a:noFill/>
+        </p:spPr>
+        <p:txBody>
+          <a:bodyPr wrap="none">
+            <a:spAutoFit/>
+          </a:bodyPr>
+          <a:lstStyle/>
+          <a:p>
+            <a:r>
+              <a:rPr sz="1200" b="0">
+                <a:solidFill>
+                  <a:srgbClr val="5B6F68"/>
+                </a:solidFill>
+                <a:latin typeface="Arial"/>
+              </a:rPr>
+              <a:t>Decode layer + override</a:t>
+            </a:r>
+          </a:p>
+        </p:txBody>
+      </p:sp>
+      <p:sp>
+        <p:nvSpPr>
+          <p:cNvPr id="17" name="Rounded Rectangle 16"/>
+          <p:cNvSpPr/>
+          <p:nvPr/>
+        </p:nvSpPr>
+        <p:spPr>
+          <a:xfrm>
+            <a:off x="640080" y="3840480"/>
+            <a:ext cx="10881360" cy="777240"/>
+          </a:xfrm>
+          <a:prstGeom prst="roundRect">
+            <a:avLst/>
+          </a:prstGeom>
+          <a:solidFill>
+            <a:srgbClr val="FFFFFF"/>
+          </a:solidFill>
+          <a:ln>
+            <a:solidFill>
+              <a:srgbClr val="D9E2DE"/>
+            </a:solidFill>
+          </a:ln>
+        </p:spPr>
+        <p:style>
+          <a:lnRef idx="1">
+            <a:schemeClr val="accent1"/>
+          </a:lnRef>
+          <a:fillRef idx="3">
+            <a:schemeClr val="accent1"/>
+          </a:fillRef>
+          <a:effectRef idx="2">
+            <a:schemeClr val="accent1"/>
+          </a:effectRef>
+          <a:fontRef idx="minor">
+            <a:schemeClr val="lt1"/>
+          </a:fontRef>
+        </p:style>
+        <p:txBody>
+          <a:bodyPr rtlCol="0" anchor="ctr"/>
+          <a:lstStyle/>
+          <a:p>
+            <a:pPr algn="ctr"/>
+          </a:p>
+        </p:txBody>
+      </p:sp>
+      <p:sp>
+        <p:nvSpPr>
+          <p:cNvPr id="18" name="TextBox 17"/>
+          <p:cNvSpPr txBox="1"/>
+          <p:nvPr/>
+        </p:nvSpPr>
+        <p:spPr>
+          <a:xfrm>
+            <a:off x="868680" y="4005072"/>
+            <a:ext cx="5029200" cy="457200"/>
+          </a:xfrm>
+          <a:prstGeom prst="rect">
+            <a:avLst/>
+          </a:prstGeom>
+          <a:noFill/>
+        </p:spPr>
+        <p:txBody>
+          <a:bodyPr wrap="none">
+            <a:spAutoFit/>
+          </a:bodyPr>
+          <a:lstStyle/>
+          <a:p>
+            <a:r>
+              <a:rPr sz="1400" b="1">
+                <a:solidFill>
+                  <a:srgbClr val="0B1F1A"/>
+                </a:solidFill>
+                <a:latin typeface="Arial"/>
+              </a:rPr>
+              <a:t>Multi-step roleplay → tools</a:t>
+            </a:r>
+          </a:p>
+        </p:txBody>
+      </p:sp>
+      <p:sp>
+        <p:nvSpPr>
+          <p:cNvPr id="19" name="TextBox 18"/>
+          <p:cNvSpPr txBox="1"/>
+          <p:nvPr/>
+        </p:nvSpPr>
+        <p:spPr>
+          <a:xfrm>
+            <a:off x="6035040" y="4005072"/>
+            <a:ext cx="2011680" cy="457200"/>
+          </a:xfrm>
+          <a:prstGeom prst="rect">
+            <a:avLst/>
+          </a:prstGeom>
+          <a:noFill/>
+        </p:spPr>
+        <p:txBody>
+          <a:bodyPr wrap="none">
+            <a:spAutoFit/>
+          </a:bodyPr>
+          <a:lstStyle/>
+          <a:p>
+            <a:r>
+              <a:rPr sz="1300" b="1">
+                <a:solidFill>
+                  <a:srgbClr val="B91C1C"/>
+                </a:solidFill>
+                <a:latin typeface="Arial"/>
+              </a:rPr>
+              <a:t>QUARANTINE / BLOCK</a:t>
+            </a:r>
+          </a:p>
+        </p:txBody>
+      </p:sp>
+      <p:sp>
+        <p:nvSpPr>
+          <p:cNvPr id="20" name="TextBox 19"/>
+          <p:cNvSpPr txBox="1"/>
+          <p:nvPr/>
+        </p:nvSpPr>
+        <p:spPr>
+          <a:xfrm>
+            <a:off x="8046720" y="4005072"/>
+            <a:ext cx="3200400" cy="457200"/>
+          </a:xfrm>
+          <a:prstGeom prst="rect">
+            <a:avLst/>
+          </a:prstGeom>
+          <a:noFill/>
+        </p:spPr>
+        <p:txBody>
+          <a:bodyPr wrap="none">
+            <a:spAutoFit/>
+          </a:bodyPr>
+          <a:lstStyle/>
+          <a:p>
+            <a:r>
+              <a:rPr sz="1200" b="0">
+                <a:solidFill>
+                  <a:srgbClr val="5B6F68"/>
+                </a:solidFill>
+                <a:latin typeface="Arial"/>
+              </a:rPr>
+              <a:t>Session risk escalation</a:t>
+            </a:r>
+          </a:p>
+        </p:txBody>
+      </p:sp>
+      <p:sp>
+        <p:nvSpPr>
+          <p:cNvPr id="21" name="Rounded Rectangle 20"/>
+          <p:cNvSpPr/>
+          <p:nvPr/>
+        </p:nvSpPr>
+        <p:spPr>
+          <a:xfrm>
+            <a:off x="640080" y="4709160"/>
+            <a:ext cx="10881360" cy="777240"/>
+          </a:xfrm>
+          <a:prstGeom prst="roundRect">
+            <a:avLst/>
+          </a:prstGeom>
+          <a:solidFill>
+            <a:srgbClr val="FFFFFF"/>
+          </a:solidFill>
+          <a:ln>
+            <a:solidFill>
+              <a:srgbClr val="D9E2DE"/>
+            </a:solidFill>
+          </a:ln>
+        </p:spPr>
+        <p:style>
+          <a:lnRef idx="1">
+            <a:schemeClr val="accent1"/>
+          </a:lnRef>
+          <a:fillRef idx="3">
+            <a:schemeClr val="accent1"/>
+          </a:fillRef>
+          <a:effectRef idx="2">
+            <a:schemeClr val="accent1"/>
+          </a:effectRef>
+          <a:fontRef idx="minor">
+            <a:schemeClr val="lt1"/>
+          </a:fontRef>
+        </p:style>
+        <p:txBody>
+          <a:bodyPr rtlCol="0" anchor="ctr"/>
+          <a:lstStyle/>
+          <a:p>
+            <a:pPr algn="ctr"/>
+          </a:p>
+        </p:txBody>
+      </p:sp>
+      <p:sp>
+        <p:nvSpPr>
+          <p:cNvPr id="22" name="TextBox 21"/>
+          <p:cNvSpPr txBox="1"/>
+          <p:nvPr/>
+        </p:nvSpPr>
+        <p:spPr>
+          <a:xfrm>
+            <a:off x="868680" y="4873752"/>
+            <a:ext cx="5029200" cy="457200"/>
+          </a:xfrm>
+          <a:prstGeom prst="rect">
+            <a:avLst/>
+          </a:prstGeom>
+          <a:noFill/>
+        </p:spPr>
+        <p:txBody>
+          <a:bodyPr wrap="none">
+            <a:spAutoFit/>
+          </a:bodyPr>
+          <a:lstStyle/>
+          <a:p>
+            <a:r>
+              <a:rPr sz="1400" b="1">
+                <a:solidFill>
+                  <a:srgbClr val="0B1F1A"/>
+                </a:solidFill>
+                <a:latin typeface="Arial"/>
+              </a:rPr>
+              <a:t>Human analyst queue</a:t>
+            </a:r>
+          </a:p>
+        </p:txBody>
+      </p:sp>
+      <p:sp>
+        <p:nvSpPr>
+          <p:cNvPr id="23" name="TextBox 22"/>
+          <p:cNvSpPr txBox="1"/>
+          <p:nvPr/>
+        </p:nvSpPr>
+        <p:spPr>
+          <a:xfrm>
+            <a:off x="6035040" y="4873752"/>
+            <a:ext cx="2011680" cy="457200"/>
+          </a:xfrm>
+          <a:prstGeom prst="rect">
+            <a:avLst/>
+          </a:prstGeom>
+          <a:noFill/>
+        </p:spPr>
+        <p:txBody>
+          <a:bodyPr wrap="none">
+            <a:spAutoFit/>
+          </a:bodyPr>
+          <a:lstStyle/>
+          <a:p>
+            <a:r>
+              <a:rPr sz="1300" b="1">
+                <a:solidFill>
+                  <a:srgbClr val="0F766E"/>
+                </a:solidFill>
+                <a:latin typeface="Arial"/>
+              </a:rPr>
+              <a:t>HITL</a:t>
+            </a:r>
+          </a:p>
+        </p:txBody>
+      </p:sp>
+      <p:sp>
+        <p:nvSpPr>
+          <p:cNvPr id="24" name="TextBox 23"/>
+          <p:cNvSpPr txBox="1"/>
+          <p:nvPr/>
+        </p:nvSpPr>
+        <p:spPr>
+          <a:xfrm>
+            <a:off x="8046720" y="4873752"/>
+            <a:ext cx="3200400" cy="457200"/>
+          </a:xfrm>
+          <a:prstGeom prst="rect">
+            <a:avLst/>
+          </a:prstGeom>
+          <a:noFill/>
+        </p:spPr>
+        <p:txBody>
+          <a:bodyPr wrap="none">
+            <a:spAutoFit/>
+          </a:bodyPr>
+          <a:lstStyle/>
+          <a:p>
+            <a:r>
+              <a:rPr sz="1200" b="0">
+                <a:solidFill>
+                  <a:srgbClr val="5B6F68"/>
+                </a:solidFill>
+                <a:latin typeface="Arial"/>
+              </a:rPr>
+              <a:t>Approve / deny with audit note</a:t>
+            </a:r>
+          </a:p>
+        </p:txBody>
+      </p:sp>
+      <p:sp>
+        <p:nvSpPr>
+          <p:cNvPr id="25" name="TextBox 24"/>
+          <p:cNvSpPr txBox="1"/>
+          <p:nvPr/>
+        </p:nvSpPr>
+        <p:spPr>
+          <a:xfrm>
+            <a:off x="548640" y="6446520"/>
+            <a:ext cx="9144000" cy="274320"/>
+          </a:xfrm>
+          <a:prstGeom prst="rect">
+            <a:avLst/>
+          </a:prstGeom>
+          <a:noFill/>
+        </p:spPr>
+        <p:txBody>
+          <a:bodyPr wrap="none">
+            <a:spAutoFit/>
+          </a:bodyPr>
+          <a:lstStyle/>
+          <a:p>
+            <a:r>
               <a:rPr sz="1000" b="0">
                 <a:solidFill>
                   <a:srgbClr val="5B6F68"/>
@@ -7449,7 +8299,7 @@
       </p:sp>
       <p:sp>
         <p:nvSpPr>
-          <p:cNvPr id="14" name="TextBox 13"/>
+          <p:cNvPr id="26" name="TextBox 25"/>
           <p:cNvSpPr txBox="1"/>
           <p:nvPr/>
         </p:nvSpPr>
@@ -7615,7 +8465,682 @@
                 </a:solidFill>
                 <a:latin typeface="Arial"/>
               </a:rPr>
-              <a:t>Business impact &amp; ask</a:t>
+              <a:t>Business impact</a:t>
+            </a:r>
+          </a:p>
+        </p:txBody>
+      </p:sp>
+      <p:sp>
+        <p:nvSpPr>
+          <p:cNvPr id="5" name="Rounded Rectangle 4"/>
+          <p:cNvSpPr/>
+          <p:nvPr/>
+        </p:nvSpPr>
+        <p:spPr>
+          <a:xfrm>
+            <a:off x="640080" y="1234440"/>
+            <a:ext cx="3566160" cy="4206240"/>
+          </a:xfrm>
+          <a:prstGeom prst="roundRect">
+            <a:avLst/>
+          </a:prstGeom>
+          <a:solidFill>
+            <a:srgbClr val="FFFFFF"/>
+          </a:solidFill>
+          <a:ln>
+            <a:solidFill>
+              <a:srgbClr val="D9E2DE"/>
+            </a:solidFill>
+          </a:ln>
+        </p:spPr>
+        <p:style>
+          <a:lnRef idx="1">
+            <a:schemeClr val="accent1"/>
+          </a:lnRef>
+          <a:fillRef idx="3">
+            <a:schemeClr val="accent1"/>
+          </a:fillRef>
+          <a:effectRef idx="2">
+            <a:schemeClr val="accent1"/>
+          </a:effectRef>
+          <a:fontRef idx="minor">
+            <a:schemeClr val="lt1"/>
+          </a:fontRef>
+        </p:style>
+        <p:txBody>
+          <a:bodyPr rtlCol="0" anchor="ctr"/>
+          <a:lstStyle/>
+          <a:p>
+            <a:pPr algn="ctr"/>
+          </a:p>
+        </p:txBody>
+      </p:sp>
+      <p:sp>
+        <p:nvSpPr>
+          <p:cNvPr id="6" name="Rectangle 5"/>
+          <p:cNvSpPr/>
+          <p:nvPr/>
+        </p:nvSpPr>
+        <p:spPr>
+          <a:xfrm>
+            <a:off x="640080" y="1234440"/>
+            <a:ext cx="73152" cy="4206240"/>
+          </a:xfrm>
+          <a:prstGeom prst="rect">
+            <a:avLst/>
+          </a:prstGeom>
+          <a:solidFill>
+            <a:srgbClr val="0F766E"/>
+          </a:solidFill>
+          <a:ln>
+            <a:noFill/>
+          </a:ln>
+        </p:spPr>
+        <p:style>
+          <a:lnRef idx="1">
+            <a:schemeClr val="accent1"/>
+          </a:lnRef>
+          <a:fillRef idx="3">
+            <a:schemeClr val="accent1"/>
+          </a:fillRef>
+          <a:effectRef idx="2">
+            <a:schemeClr val="accent1"/>
+          </a:effectRef>
+          <a:fontRef idx="minor">
+            <a:schemeClr val="lt1"/>
+          </a:fontRef>
+        </p:style>
+        <p:txBody>
+          <a:bodyPr rtlCol="0" anchor="ctr"/>
+          <a:lstStyle/>
+          <a:p>
+            <a:pPr algn="ctr"/>
+          </a:p>
+        </p:txBody>
+      </p:sp>
+      <p:sp>
+        <p:nvSpPr>
+          <p:cNvPr id="7" name="TextBox 6"/>
+          <p:cNvSpPr txBox="1"/>
+          <p:nvPr/>
+        </p:nvSpPr>
+        <p:spPr>
+          <a:xfrm>
+            <a:off x="868680" y="1417320"/>
+            <a:ext cx="3200400" cy="365760"/>
+          </a:xfrm>
+          <a:prstGeom prst="rect">
+            <a:avLst/>
+          </a:prstGeom>
+          <a:noFill/>
+        </p:spPr>
+        <p:txBody>
+          <a:bodyPr wrap="none">
+            <a:spAutoFit/>
+          </a:bodyPr>
+          <a:lstStyle/>
+          <a:p>
+            <a:r>
+              <a:rPr sz="1400" b="1">
+                <a:solidFill>
+                  <a:srgbClr val="115E59"/>
+                </a:solidFill>
+                <a:latin typeface="Arial"/>
+              </a:rPr>
+              <a:t>Risk reduction</a:t>
+            </a:r>
+          </a:p>
+        </p:txBody>
+      </p:sp>
+      <p:sp>
+        <p:nvSpPr>
+          <p:cNvPr id="8" name="TextBox 7"/>
+          <p:cNvSpPr txBox="1"/>
+          <p:nvPr/>
+        </p:nvSpPr>
+        <p:spPr>
+          <a:xfrm>
+            <a:off x="868680" y="1828800"/>
+            <a:ext cx="3200400" cy="3428999"/>
+          </a:xfrm>
+          <a:prstGeom prst="rect">
+            <a:avLst/>
+          </a:prstGeom>
+          <a:noFill/>
+        </p:spPr>
+        <p:txBody>
+          <a:bodyPr wrap="square">
+            <a:spAutoFit/>
+          </a:bodyPr>
+          <a:lstStyle/>
+          <a:p>
+            <a:r>
+              <a:rPr sz="1200" b="0">
+                <a:solidFill>
+                  <a:srgbClr val="5B6F68"/>
+                </a:solidFill>
+                <a:latin typeface="Arial"/>
+              </a:rPr>
+              <a:t>Block secret theft and tool abuse before execution — agents stay useful on benign documents.</a:t>
+            </a:r>
+          </a:p>
+        </p:txBody>
+      </p:sp>
+      <p:sp>
+        <p:nvSpPr>
+          <p:cNvPr id="9" name="Rounded Rectangle 8"/>
+          <p:cNvSpPr/>
+          <p:nvPr/>
+        </p:nvSpPr>
+        <p:spPr>
+          <a:xfrm>
+            <a:off x="4389120" y="1234440"/>
+            <a:ext cx="3566160" cy="4206240"/>
+          </a:xfrm>
+          <a:prstGeom prst="roundRect">
+            <a:avLst/>
+          </a:prstGeom>
+          <a:solidFill>
+            <a:srgbClr val="FFFFFF"/>
+          </a:solidFill>
+          <a:ln>
+            <a:solidFill>
+              <a:srgbClr val="D9E2DE"/>
+            </a:solidFill>
+          </a:ln>
+        </p:spPr>
+        <p:style>
+          <a:lnRef idx="1">
+            <a:schemeClr val="accent1"/>
+          </a:lnRef>
+          <a:fillRef idx="3">
+            <a:schemeClr val="accent1"/>
+          </a:fillRef>
+          <a:effectRef idx="2">
+            <a:schemeClr val="accent1"/>
+          </a:effectRef>
+          <a:fontRef idx="minor">
+            <a:schemeClr val="lt1"/>
+          </a:fontRef>
+        </p:style>
+        <p:txBody>
+          <a:bodyPr rtlCol="0" anchor="ctr"/>
+          <a:lstStyle/>
+          <a:p>
+            <a:pPr algn="ctr"/>
+          </a:p>
+        </p:txBody>
+      </p:sp>
+      <p:sp>
+        <p:nvSpPr>
+          <p:cNvPr id="10" name="Rectangle 9"/>
+          <p:cNvSpPr/>
+          <p:nvPr/>
+        </p:nvSpPr>
+        <p:spPr>
+          <a:xfrm>
+            <a:off x="4389120" y="1234440"/>
+            <a:ext cx="73152" cy="4206240"/>
+          </a:xfrm>
+          <a:prstGeom prst="rect">
+            <a:avLst/>
+          </a:prstGeom>
+          <a:solidFill>
+            <a:srgbClr val="0F766E"/>
+          </a:solidFill>
+          <a:ln>
+            <a:noFill/>
+          </a:ln>
+        </p:spPr>
+        <p:style>
+          <a:lnRef idx="1">
+            <a:schemeClr val="accent1"/>
+          </a:lnRef>
+          <a:fillRef idx="3">
+            <a:schemeClr val="accent1"/>
+          </a:fillRef>
+          <a:effectRef idx="2">
+            <a:schemeClr val="accent1"/>
+          </a:effectRef>
+          <a:fontRef idx="minor">
+            <a:schemeClr val="lt1"/>
+          </a:fontRef>
+        </p:style>
+        <p:txBody>
+          <a:bodyPr rtlCol="0" anchor="ctr"/>
+          <a:lstStyle/>
+          <a:p>
+            <a:pPr algn="ctr"/>
+          </a:p>
+        </p:txBody>
+      </p:sp>
+      <p:sp>
+        <p:nvSpPr>
+          <p:cNvPr id="11" name="TextBox 10"/>
+          <p:cNvSpPr txBox="1"/>
+          <p:nvPr/>
+        </p:nvSpPr>
+        <p:spPr>
+          <a:xfrm>
+            <a:off x="4617720" y="1417320"/>
+            <a:ext cx="3200400" cy="365760"/>
+          </a:xfrm>
+          <a:prstGeom prst="rect">
+            <a:avLst/>
+          </a:prstGeom>
+          <a:noFill/>
+        </p:spPr>
+        <p:txBody>
+          <a:bodyPr wrap="none">
+            <a:spAutoFit/>
+          </a:bodyPr>
+          <a:lstStyle/>
+          <a:p>
+            <a:r>
+              <a:rPr sz="1400" b="1">
+                <a:solidFill>
+                  <a:srgbClr val="115E59"/>
+                </a:solidFill>
+                <a:latin typeface="Arial"/>
+              </a:rPr>
+              <a:t>Audit &amp; governance</a:t>
+            </a:r>
+          </a:p>
+        </p:txBody>
+      </p:sp>
+      <p:sp>
+        <p:nvSpPr>
+          <p:cNvPr id="12" name="TextBox 11"/>
+          <p:cNvSpPr txBox="1"/>
+          <p:nvPr/>
+        </p:nvSpPr>
+        <p:spPr>
+          <a:xfrm>
+            <a:off x="4617720" y="1828800"/>
+            <a:ext cx="3200400" cy="3428999"/>
+          </a:xfrm>
+          <a:prstGeom prst="rect">
+            <a:avLst/>
+          </a:prstGeom>
+          <a:noFill/>
+        </p:spPr>
+        <p:txBody>
+          <a:bodyPr wrap="square">
+            <a:spAutoFit/>
+          </a:bodyPr>
+          <a:lstStyle/>
+          <a:p>
+            <a:r>
+              <a:rPr sz="1200" b="0">
+                <a:solidFill>
+                  <a:srgbClr val="5B6F68"/>
+                </a:solidFill>
+                <a:latin typeface="Arial"/>
+              </a:rPr>
+              <a:t>Incident JSON, decision trails, OWASP LLM Top 10 &amp; NIST AI RMF mapped controls for security teams.</a:t>
+            </a:r>
+          </a:p>
+        </p:txBody>
+      </p:sp>
+      <p:sp>
+        <p:nvSpPr>
+          <p:cNvPr id="13" name="Rounded Rectangle 12"/>
+          <p:cNvSpPr/>
+          <p:nvPr/>
+        </p:nvSpPr>
+        <p:spPr>
+          <a:xfrm>
+            <a:off x="8138160" y="1234440"/>
+            <a:ext cx="3383280" cy="4206240"/>
+          </a:xfrm>
+          <a:prstGeom prst="roundRect">
+            <a:avLst/>
+          </a:prstGeom>
+          <a:solidFill>
+            <a:srgbClr val="FFFFFF"/>
+          </a:solidFill>
+          <a:ln>
+            <a:solidFill>
+              <a:srgbClr val="D9E2DE"/>
+            </a:solidFill>
+          </a:ln>
+        </p:spPr>
+        <p:style>
+          <a:lnRef idx="1">
+            <a:schemeClr val="accent1"/>
+          </a:lnRef>
+          <a:fillRef idx="3">
+            <a:schemeClr val="accent1"/>
+          </a:fillRef>
+          <a:effectRef idx="2">
+            <a:schemeClr val="accent1"/>
+          </a:effectRef>
+          <a:fontRef idx="minor">
+            <a:schemeClr val="lt1"/>
+          </a:fontRef>
+        </p:style>
+        <p:txBody>
+          <a:bodyPr rtlCol="0" anchor="ctr"/>
+          <a:lstStyle/>
+          <a:p>
+            <a:pPr algn="ctr"/>
+          </a:p>
+        </p:txBody>
+      </p:sp>
+      <p:sp>
+        <p:nvSpPr>
+          <p:cNvPr id="14" name="Rectangle 13"/>
+          <p:cNvSpPr/>
+          <p:nvPr/>
+        </p:nvSpPr>
+        <p:spPr>
+          <a:xfrm>
+            <a:off x="8138160" y="1234440"/>
+            <a:ext cx="73152" cy="4206240"/>
+          </a:xfrm>
+          <a:prstGeom prst="rect">
+            <a:avLst/>
+          </a:prstGeom>
+          <a:solidFill>
+            <a:srgbClr val="0F766E"/>
+          </a:solidFill>
+          <a:ln>
+            <a:noFill/>
+          </a:ln>
+        </p:spPr>
+        <p:style>
+          <a:lnRef idx="1">
+            <a:schemeClr val="accent1"/>
+          </a:lnRef>
+          <a:fillRef idx="3">
+            <a:schemeClr val="accent1"/>
+          </a:fillRef>
+          <a:effectRef idx="2">
+            <a:schemeClr val="accent1"/>
+          </a:effectRef>
+          <a:fontRef idx="minor">
+            <a:schemeClr val="lt1"/>
+          </a:fontRef>
+        </p:style>
+        <p:txBody>
+          <a:bodyPr rtlCol="0" anchor="ctr"/>
+          <a:lstStyle/>
+          <a:p>
+            <a:pPr algn="ctr"/>
+          </a:p>
+        </p:txBody>
+      </p:sp>
+      <p:sp>
+        <p:nvSpPr>
+          <p:cNvPr id="15" name="TextBox 14"/>
+          <p:cNvSpPr txBox="1"/>
+          <p:nvPr/>
+        </p:nvSpPr>
+        <p:spPr>
+          <a:xfrm>
+            <a:off x="8366760" y="1417320"/>
+            <a:ext cx="3017520" cy="365760"/>
+          </a:xfrm>
+          <a:prstGeom prst="rect">
+            <a:avLst/>
+          </a:prstGeom>
+          <a:noFill/>
+        </p:spPr>
+        <p:txBody>
+          <a:bodyPr wrap="none">
+            <a:spAutoFit/>
+          </a:bodyPr>
+          <a:lstStyle/>
+          <a:p>
+            <a:r>
+              <a:rPr sz="1400" b="1">
+                <a:solidFill>
+                  <a:srgbClr val="115E59"/>
+                </a:solidFill>
+                <a:latin typeface="Arial"/>
+              </a:rPr>
+              <a:t>Human oversight</a:t>
+            </a:r>
+          </a:p>
+        </p:txBody>
+      </p:sp>
+      <p:sp>
+        <p:nvSpPr>
+          <p:cNvPr id="16" name="TextBox 15"/>
+          <p:cNvSpPr txBox="1"/>
+          <p:nvPr/>
+        </p:nvSpPr>
+        <p:spPr>
+          <a:xfrm>
+            <a:off x="8366760" y="1828800"/>
+            <a:ext cx="3017520" cy="3428999"/>
+          </a:xfrm>
+          <a:prstGeom prst="rect">
+            <a:avLst/>
+          </a:prstGeom>
+          <a:noFill/>
+        </p:spPr>
+        <p:txBody>
+          <a:bodyPr wrap="square">
+            <a:spAutoFit/>
+          </a:bodyPr>
+          <a:lstStyle/>
+          <a:p>
+            <a:r>
+              <a:rPr sz="1200" b="0">
+                <a:solidFill>
+                  <a:srgbClr val="5B6F68"/>
+                </a:solidFill>
+                <a:latin typeface="Arial"/>
+              </a:rPr>
+              <a:t>Quarantine band keeps analysts in the loop for ambiguous cases — fail-closed on high risk.</a:t>
+            </a:r>
+          </a:p>
+        </p:txBody>
+      </p:sp>
+      <p:sp>
+        <p:nvSpPr>
+          <p:cNvPr id="17" name="TextBox 16"/>
+          <p:cNvSpPr txBox="1"/>
+          <p:nvPr/>
+        </p:nvSpPr>
+        <p:spPr>
+          <a:xfrm>
+            <a:off x="548640" y="6446520"/>
+            <a:ext cx="9144000" cy="274320"/>
+          </a:xfrm>
+          <a:prstGeom prst="rect">
+            <a:avLst/>
+          </a:prstGeom>
+          <a:noFill/>
+        </p:spPr>
+        <p:txBody>
+          <a:bodyPr wrap="none">
+            <a:spAutoFit/>
+          </a:bodyPr>
+          <a:lstStyle/>
+          <a:p>
+            <a:r>
+              <a:rPr sz="1000" b="0">
+                <a:solidFill>
+                  <a:srgbClr val="5B6F68"/>
+                </a:solidFill>
+                <a:latin typeface="Arial"/>
+              </a:rPr>
+              <a:t>Aegis Guard  ·  ET AI Hackathon Problem 2  ·  Claim F3 / D2  ·  08</a:t>
+            </a:r>
+          </a:p>
+        </p:txBody>
+      </p:sp>
+      <p:sp>
+        <p:nvSpPr>
+          <p:cNvPr id="18" name="TextBox 17"/>
+          <p:cNvSpPr txBox="1"/>
+          <p:nvPr/>
+        </p:nvSpPr>
+        <p:spPr>
+          <a:xfrm>
+            <a:off x="10241280" y="6446520"/>
+            <a:ext cx="1371600" cy="274320"/>
+          </a:xfrm>
+          <a:prstGeom prst="rect">
+            <a:avLst/>
+          </a:prstGeom>
+          <a:noFill/>
+        </p:spPr>
+        <p:txBody>
+          <a:bodyPr wrap="none">
+            <a:spAutoFit/>
+          </a:bodyPr>
+          <a:lstStyle/>
+          <a:p>
+            <a:pPr algn="r"/>
+            <a:r>
+              <a:rPr sz="1000" b="0">
+                <a:solidFill>
+                  <a:srgbClr val="5B6F68"/>
+                </a:solidFill>
+                <a:latin typeface="Arial"/>
+              </a:rPr>
+              <a:t>08</a:t>
+            </a:r>
+          </a:p>
+        </p:txBody>
+      </p:sp>
+    </p:spTree>
+  </p:cSld>
+  <p:clrMapOvr>
+    <a:masterClrMapping/>
+  </p:clrMapOvr>
+</p:sld>
+</file>
+
+<file path=ppt/slides/slide9.xml><?xml version="1.0" encoding="utf-8"?>
+<p:sld xmlns:a="http://schemas.openxmlformats.org/drawingml/2006/main" xmlns:p="http://schemas.openxmlformats.org/presentationml/2006/main" xmlns:r="http://schemas.openxmlformats.org/officeDocument/2006/relationships">
+  <p:cSld>
+    <p:spTree>
+      <p:nvGrpSpPr>
+        <p:cNvPr id="1" name=""/>
+        <p:cNvGrpSpPr/>
+        <p:nvPr/>
+      </p:nvGrpSpPr>
+      <p:grpSpPr/>
+      <p:sp>
+        <p:nvSpPr>
+          <p:cNvPr id="2" name="Rectangle 1"/>
+          <p:cNvSpPr/>
+          <p:nvPr/>
+        </p:nvSpPr>
+        <p:spPr>
+          <a:xfrm>
+            <a:off x="0" y="0"/>
+            <a:ext cx="12191695" cy="6858000"/>
+          </a:xfrm>
+          <a:prstGeom prst="rect">
+            <a:avLst/>
+          </a:prstGeom>
+          <a:solidFill>
+            <a:srgbClr val="F4F7F6"/>
+          </a:solidFill>
+          <a:ln>
+            <a:noFill/>
+          </a:ln>
+        </p:spPr>
+        <p:style>
+          <a:lnRef idx="1">
+            <a:schemeClr val="accent1"/>
+          </a:lnRef>
+          <a:fillRef idx="3">
+            <a:schemeClr val="accent1"/>
+          </a:fillRef>
+          <a:effectRef idx="2">
+            <a:schemeClr val="accent1"/>
+          </a:effectRef>
+          <a:fontRef idx="minor">
+            <a:schemeClr val="lt1"/>
+          </a:fontRef>
+        </p:style>
+        <p:txBody>
+          <a:bodyPr rtlCol="0" anchor="ctr"/>
+          <a:lstStyle/>
+          <a:p>
+            <a:pPr algn="ctr"/>
+          </a:p>
+        </p:txBody>
+      </p:sp>
+      <p:sp>
+        <p:nvSpPr>
+          <p:cNvPr id="3" name="Rectangle 2"/>
+          <p:cNvSpPr/>
+          <p:nvPr/>
+        </p:nvSpPr>
+        <p:spPr>
+          <a:xfrm>
+            <a:off x="0" y="0"/>
+            <a:ext cx="12191695" cy="73152"/>
+          </a:xfrm>
+          <a:prstGeom prst="rect">
+            <a:avLst/>
+          </a:prstGeom>
+          <a:solidFill>
+            <a:srgbClr val="0F766E"/>
+          </a:solidFill>
+          <a:ln>
+            <a:noFill/>
+          </a:ln>
+        </p:spPr>
+        <p:style>
+          <a:lnRef idx="1">
+            <a:schemeClr val="accent1"/>
+          </a:lnRef>
+          <a:fillRef idx="3">
+            <a:schemeClr val="accent1"/>
+          </a:fillRef>
+          <a:effectRef idx="2">
+            <a:schemeClr val="accent1"/>
+          </a:effectRef>
+          <a:fontRef idx="minor">
+            <a:schemeClr val="lt1"/>
+          </a:fontRef>
+        </p:style>
+        <p:txBody>
+          <a:bodyPr rtlCol="0" anchor="ctr"/>
+          <a:lstStyle/>
+          <a:p>
+            <a:pPr algn="ctr"/>
+          </a:p>
+        </p:txBody>
+      </p:sp>
+      <p:sp>
+        <p:nvSpPr>
+          <p:cNvPr id="4" name="TextBox 3"/>
+          <p:cNvSpPr txBox="1"/>
+          <p:nvPr/>
+        </p:nvSpPr>
+        <p:spPr>
+          <a:xfrm>
+            <a:off x="640080" y="411480"/>
+            <a:ext cx="10972800" cy="640080"/>
+          </a:xfrm>
+          <a:prstGeom prst="rect">
+            <a:avLst/>
+          </a:prstGeom>
+          <a:noFill/>
+        </p:spPr>
+        <p:txBody>
+          <a:bodyPr wrap="none">
+            <a:spAutoFit/>
+          </a:bodyPr>
+          <a:lstStyle/>
+          <a:p>
+            <a:r>
+              <a:rPr sz="3200" b="1">
+                <a:solidFill>
+                  <a:srgbClr val="0B1F1A"/>
+                </a:solidFill>
+                <a:latin typeface="Arial"/>
+              </a:rPr>
+              <a:t>Scalability</a:t>
             </a:r>
           </a:p>
         </p:txBody>
@@ -7648,13 +9173,13 @@
               </a:spcAft>
             </a:pPr>
             <a:r>
-              <a:rPr sz="1500" b="0">
+              <a:rPr sz="1600" b="0">
                 <a:solidFill>
                   <a:srgbClr val="0B1F1A"/>
                 </a:solidFill>
                 <a:latin typeface="Arial"/>
               </a:rPr>
-              <a:t>Measurable outcomes for enterprises deploying agents:</a:t>
+              <a:t>Designed as a side-car control plane in front of any tool-using agent:</a:t>
             </a:r>
           </a:p>
           <a:p>
@@ -7664,13 +9189,13 @@
               </a:spcAft>
             </a:pPr>
             <a:r>
-              <a:rPr sz="1500" b="0">
+              <a:rPr sz="1600" b="0">
                 <a:solidFill>
                   <a:srgbClr val="5B6F68"/>
                 </a:solidFill>
                 <a:latin typeface="Arial"/>
               </a:rPr>
-              <a:t>  • Risk reduction — block secret theft and tool abuse before execution</a:t>
+              <a:t>  • Stateless scan API — horizontal scale behind a load balancer</a:t>
             </a:r>
           </a:p>
           <a:p>
@@ -7680,13 +9205,13 @@
               </a:spcAft>
             </a:pPr>
             <a:r>
-              <a:rPr sz="1500" b="0">
+              <a:rPr sz="1600" b="0">
                 <a:solidFill>
                   <a:srgbClr val="5B6F68"/>
                 </a:solidFill>
                 <a:latin typeface="Arial"/>
               </a:rPr>
-              <a:t>  • Auditability — incident JSON + decision trail for security teams</a:t>
+              <a:t>  • Offline twin by default — predictable latency without LLM round-trips</a:t>
             </a:r>
           </a:p>
           <a:p>
@@ -7696,13 +9221,13 @@
               </a:spcAft>
             </a:pPr>
             <a:r>
-              <a:rPr sz="1500" b="0">
+              <a:rPr sz="1600" b="0">
                 <a:solidFill>
                   <a:srgbClr val="5B6F68"/>
                 </a:solidFill>
                 <a:latin typeface="Arial"/>
               </a:rPr>
-              <a:t>  • Governance — OWASP LLM Top 10 &amp; NIST AI RMF mapped controls</a:t>
+              <a:t>  • Optional LLM planner only where enrichment adds value</a:t>
             </a:r>
           </a:p>
           <a:p>
@@ -7712,13 +9237,13 @@
               </a:spcAft>
             </a:pPr>
             <a:r>
-              <a:rPr sz="1500" b="0">
+              <a:rPr sz="1600" b="0">
                 <a:solidFill>
                   <a:srgbClr val="5B6F68"/>
                 </a:solidFill>
                 <a:latin typeface="Arial"/>
               </a:rPr>
-              <a:t>  • Human oversight — quarantine band keeps humans in the loop</a:t>
+              <a:t>  • SQLite today → Postgres / object storage for multi-tenant audit at scale</a:t>
             </a:r>
           </a:p>
           <a:p>
@@ -7728,13 +9253,13 @@
               </a:spcAft>
             </a:pPr>
             <a:r>
-              <a:rPr sz="1500" b="0">
-                <a:solidFill>
-                  <a:srgbClr val="0B1F1A"/>
-                </a:solidFill>
-                <a:latin typeface="Arial"/>
-              </a:rPr>
-              <a:t/>
+              <a:rPr sz="1600" b="0">
+                <a:solidFill>
+                  <a:srgbClr val="5B6F68"/>
+                </a:solidFill>
+                <a:latin typeface="Arial"/>
+              </a:rPr>
+              <a:t>  • Capability tokens enforce least privilege per tenant / agent role</a:t>
             </a:r>
           </a:p>
           <a:p>
@@ -7744,13 +9269,13 @@
               </a:spcAft>
             </a:pPr>
             <a:r>
-              <a:rPr sz="1500" b="0">
-                <a:solidFill>
-                  <a:srgbClr val="0B1F1A"/>
-                </a:solidFill>
-                <a:latin typeface="Arial"/>
-              </a:rPr>
-              <a:t>Live: https://aegis-prompt-injection-firewall.vercel.app</a:t>
+              <a:rPr sz="1600" b="0">
+                <a:solidFill>
+                  <a:srgbClr val="5B6F68"/>
+                </a:solidFill>
+                <a:latin typeface="Arial"/>
+              </a:rPr>
+              <a:t>  • Corpus + pytest gate regressions as detectors grow</a:t>
             </a:r>
           </a:p>
           <a:p>
@@ -7760,13 +9285,13 @@
               </a:spcAft>
             </a:pPr>
             <a:r>
-              <a:rPr sz="1500" b="0">
+              <a:rPr sz="1600" b="0">
                 <a:solidFill>
                   <a:srgbClr val="0B1F1A"/>
                 </a:solidFill>
                 <a:latin typeface="Arial"/>
               </a:rPr>
-              <a:t>Code: https://github.com/krabhi75/aegis-prompt-injection-firewall</a:t>
+              <a:t/>
             </a:r>
           </a:p>
           <a:p>
@@ -7776,77 +9301,13 @@
               </a:spcAft>
             </a:pPr>
             <a:r>
-              <a:rPr sz="1500" b="0">
+              <a:rPr sz="1600" b="0">
                 <a:solidFill>
                   <a:srgbClr val="0B1F1A"/>
                 </a:solidFill>
                 <a:latin typeface="Arial"/>
               </a:rPr>
-              <a:t/>
-            </a:r>
-          </a:p>
-          <a:p>
-            <a:pPr>
-              <a:spcAft>
-                <a:spcPts val="800"/>
-              </a:spcAft>
-            </a:pPr>
-            <a:r>
-              <a:rPr sz="1500" b="0">
-                <a:solidFill>
-                  <a:srgbClr val="0B1F1A"/>
-                </a:solidFill>
-                <a:latin typeface="Arial"/>
-              </a:rPr>
-              <a:t>Closer:</a:t>
-            </a:r>
-          </a:p>
-          <a:p>
-            <a:pPr>
-              <a:spcAft>
-                <a:spcPts val="800"/>
-              </a:spcAft>
-            </a:pPr>
-            <a:r>
-              <a:rPr sz="1500" b="0">
-                <a:solidFill>
-                  <a:srgbClr val="5B6F68"/>
-                </a:solidFill>
-                <a:latin typeface="Arial"/>
-              </a:rPr>
-              <a:t>  Everyone else ships a classifier. We ship a twin.</a:t>
-            </a:r>
-          </a:p>
-          <a:p>
-            <a:pPr>
-              <a:spcAft>
-                <a:spcPts val="800"/>
-              </a:spcAft>
-            </a:pPr>
-            <a:r>
-              <a:rPr sz="1500" b="0">
-                <a:solidFill>
-                  <a:srgbClr val="5B6F68"/>
-                </a:solidFill>
-                <a:latin typeface="Arial"/>
-              </a:rPr>
-              <a:t>  If the document tries to make your agent steal secrets,</a:t>
-            </a:r>
-          </a:p>
-          <a:p>
-            <a:pPr>
-              <a:spcAft>
-                <a:spcPts val="800"/>
-              </a:spcAft>
-            </a:pPr>
-            <a:r>
-              <a:rPr sz="1500" b="0">
-                <a:solidFill>
-                  <a:srgbClr val="5B6F68"/>
-                </a:solidFill>
-                <a:latin typeface="Arial"/>
-              </a:rPr>
-              <a:t>  the plans diverge — and Aegis blocks before a single tool runs.</a:t>
+              <a:t>Same pattern works for email triage, ticket agents, and document copilots.</a:t>
             </a:r>
           </a:p>
         </p:txBody>
@@ -7880,7 +9341,7 @@
                 </a:solidFill>
                 <a:latin typeface="Arial"/>
               </a:rPr>
-              <a:t>Aegis Guard  ·  ET AI Hackathon Problem 2  ·  Claim F3 / D2  ·  08</a:t>
+              <a:t>Aegis Guard  ·  ET AI Hackathon Problem 2  ·  Claim F3 / D2  ·  09</a:t>
             </a:r>
           </a:p>
         </p:txBody>
@@ -7915,7 +9376,7 @@
                 </a:solidFill>
                 <a:latin typeface="Arial"/>
               </a:rPr>
-              <a:t>08</a:t>
+              <a:t>09</a:t>
             </a:r>
           </a:p>
         </p:txBody>

</xml_diff>